<commit_message>
chore: update vercel deployment URL in presentation
</commit_message>
<xml_diff>
--- a/BridgeGuard_ML_Review_II.pptx
+++ b/BridgeGuard_ML_Review_II.pptx
@@ -4,28 +4,25 @@
   <p:sldMasterIdLst>
     <p:sldMasterId id="2147483648" r:id="rId1"/>
   </p:sldMasterIdLst>
-  <p:notesMasterIdLst>
-    <p:notesMasterId r:id="rId18"/>
-  </p:notesMasterIdLst>
   <p:sldIdLst>
-    <p:sldId id="256" r:id="rId2"/>
-    <p:sldId id="257" r:id="rId3"/>
-    <p:sldId id="258" r:id="rId4"/>
-    <p:sldId id="259" r:id="rId5"/>
-    <p:sldId id="260" r:id="rId6"/>
-    <p:sldId id="261" r:id="rId7"/>
-    <p:sldId id="262" r:id="rId8"/>
-    <p:sldId id="263" r:id="rId9"/>
-    <p:sldId id="264" r:id="rId10"/>
-    <p:sldId id="265" r:id="rId11"/>
-    <p:sldId id="266" r:id="rId12"/>
-    <p:sldId id="267" r:id="rId13"/>
-    <p:sldId id="268" r:id="rId14"/>
-    <p:sldId id="269" r:id="rId15"/>
-    <p:sldId id="270" r:id="rId16"/>
-    <p:sldId id="271" r:id="rId17"/>
+    <p:sldId id="256" r:id="rId7"/>
+    <p:sldId id="257" r:id="rId9"/>
+    <p:sldId id="258" r:id="rId10"/>
+    <p:sldId id="259" r:id="rId11"/>
+    <p:sldId id="260" r:id="rId12"/>
+    <p:sldId id="261" r:id="rId13"/>
+    <p:sldId id="262" r:id="rId14"/>
+    <p:sldId id="263" r:id="rId15"/>
+    <p:sldId id="264" r:id="rId16"/>
+    <p:sldId id="265" r:id="rId17"/>
+    <p:sldId id="266" r:id="rId18"/>
+    <p:sldId id="267" r:id="rId19"/>
+    <p:sldId id="268" r:id="rId20"/>
+    <p:sldId id="269" r:id="rId21"/>
+    <p:sldId id="270" r:id="rId22"/>
+    <p:sldId id="271" r:id="rId23"/>
   </p:sldIdLst>
-  <p:sldSz cx="12192000" cy="6858000"/>
+  <p:sldSz cx="12191695" cy="6858000" type="screen4x3"/>
   <p:notesSz cx="6858000" cy="9144000"/>
   <p:defaultTextStyle>
     <a:defPPr>
@@ -122,87 +119,11 @@
       </a:defRPr>
     </a:lvl9pPr>
   </p:defaultTextStyle>
-  <p:extLst>
-    <p:ext uri="{EFAFB233-063F-42B5-8137-9DF3F51BA10A}">
-      <p15:sldGuideLst xmlns:p15="http://schemas.microsoft.com/office/powerpoint/2012/main">
-        <p15:guide id="1" orient="horz" pos="2160">
-          <p15:clr>
-            <a:srgbClr val="A4A3A4"/>
-          </p15:clr>
-        </p15:guide>
-        <p15:guide id="2" pos="2880">
-          <p15:clr>
-            <a:srgbClr val="A4A3A4"/>
-          </p15:clr>
-        </p15:guide>
-      </p15:sldGuideLst>
-    </p:ext>
-  </p:extLst>
 </p:presentation>
 </file>
 
-<file path=ppt/changesInfos/changesInfo1.xml><?xml version="1.0" encoding="utf-8"?>
-<pc:chgInfo xmlns:a="http://schemas.openxmlformats.org/drawingml/2006/main" xmlns:r="http://schemas.openxmlformats.org/officeDocument/2006/relationships" xmlns:ac="http://schemas.microsoft.com/office/drawing/2013/main/command" xmlns:pc="http://schemas.microsoft.com/office/powerpoint/2013/main/command">
-  <pc:docChgLst>
-    <pc:chgData name="avula tarun" userId="971a0ab05f112b0a" providerId="LiveId" clId="{BA2F2C09-4EF8-403F-BFCC-AFEB6DB3976D}"/>
-    <pc:docChg chg="undo custSel modSld">
-      <pc:chgData name="avula tarun" userId="971a0ab05f112b0a" providerId="LiveId" clId="{BA2F2C09-4EF8-403F-BFCC-AFEB6DB3976D}" dt="2026-09-22T14:28:29.367" v="8" actId="1076"/>
-      <pc:docMkLst>
-        <pc:docMk/>
-      </pc:docMkLst>
-      <pc:sldChg chg="modSp mod">
-        <pc:chgData name="avula tarun" userId="971a0ab05f112b0a" providerId="LiveId" clId="{BA2F2C09-4EF8-403F-BFCC-AFEB6DB3976D}" dt="2026-09-22T14:26:14.850" v="0" actId="20577"/>
-        <pc:sldMkLst>
-          <pc:docMk/>
-          <pc:sldMk cId="0" sldId="258"/>
-        </pc:sldMkLst>
-        <pc:spChg chg="mod">
-          <ac:chgData name="avula tarun" userId="971a0ab05f112b0a" providerId="LiveId" clId="{BA2F2C09-4EF8-403F-BFCC-AFEB6DB3976D}" dt="2026-09-22T14:26:14.850" v="0" actId="20577"/>
-          <ac:spMkLst>
-            <pc:docMk/>
-            <pc:sldMk cId="0" sldId="258"/>
-            <ac:spMk id="5" creationId="{00000000-0000-0000-0000-000000000000}"/>
-          </ac:spMkLst>
-        </pc:spChg>
-      </pc:sldChg>
-      <pc:sldChg chg="addSp delSp modSp mod">
-        <pc:chgData name="avula tarun" userId="971a0ab05f112b0a" providerId="LiveId" clId="{BA2F2C09-4EF8-403F-BFCC-AFEB6DB3976D}" dt="2026-09-22T14:28:29.367" v="8" actId="1076"/>
-        <pc:sldMkLst>
-          <pc:docMk/>
-          <pc:sldMk cId="0" sldId="269"/>
-        </pc:sldMkLst>
-        <pc:spChg chg="del mod">
-          <ac:chgData name="avula tarun" userId="971a0ab05f112b0a" providerId="LiveId" clId="{BA2F2C09-4EF8-403F-BFCC-AFEB6DB3976D}" dt="2026-09-22T14:28:09.376" v="2" actId="478"/>
-          <ac:spMkLst>
-            <pc:docMk/>
-            <pc:sldMk cId="0" sldId="269"/>
-            <ac:spMk id="5" creationId="{00000000-0000-0000-0000-000000000000}"/>
-          </ac:spMkLst>
-        </pc:spChg>
-        <pc:spChg chg="add del">
-          <ac:chgData name="avula tarun" userId="971a0ab05f112b0a" providerId="LiveId" clId="{BA2F2C09-4EF8-403F-BFCC-AFEB6DB3976D}" dt="2026-09-22T14:28:13.633" v="4" actId="22"/>
-          <ac:spMkLst>
-            <pc:docMk/>
-            <pc:sldMk cId="0" sldId="269"/>
-            <ac:spMk id="7" creationId="{A8C9FBEB-F139-1423-6E74-A3555441CD1D}"/>
-          </ac:spMkLst>
-        </pc:spChg>
-        <pc:picChg chg="add mod">
-          <ac:chgData name="avula tarun" userId="971a0ab05f112b0a" providerId="LiveId" clId="{BA2F2C09-4EF8-403F-BFCC-AFEB6DB3976D}" dt="2026-09-22T14:28:29.367" v="8" actId="1076"/>
-          <ac:picMkLst>
-            <pc:docMk/>
-            <pc:sldMk cId="0" sldId="269"/>
-            <ac:picMk id="9" creationId="{5EDFECE5-173C-6064-FA2E-12ABFA5F733D}"/>
-          </ac:picMkLst>
-        </pc:picChg>
-      </pc:sldChg>
-    </pc:docChg>
-  </pc:docChgLst>
-</pc:chgInfo>
-</file>
-
 <file path=ppt/notesMasters/notesMaster1.xml><?xml version="1.0" encoding="utf-8"?>
-<p:notesMaster xmlns:a="http://schemas.openxmlformats.org/drawingml/2006/main" xmlns:r="http://schemas.openxmlformats.org/officeDocument/2006/relationships" xmlns:p="http://schemas.openxmlformats.org/presentationml/2006/main">
+<p:notesMaster xmlns:a="http://schemas.openxmlformats.org/drawingml/2006/main" xmlns:p="http://schemas.openxmlformats.org/presentationml/2006/main" xmlns:r="http://schemas.openxmlformats.org/officeDocument/2006/relationships">
   <p:cSld>
     <p:bg>
       <p:bgRef idx="1001">
@@ -223,16 +144,241 @@
           <a:chExt cx="0" cy="0"/>
         </a:xfrm>
       </p:grpSpPr>
+      <p:sp>
+        <p:nvSpPr>
+          <p:cNvPr id="2" name="Header Placeholder 1"/>
+          <p:cNvSpPr>
+            <a:spLocks noGrp="1"/>
+          </p:cNvSpPr>
+          <p:nvPr>
+            <p:ph type="hdr" sz="quarter"/>
+          </p:nvPr>
+        </p:nvSpPr>
+        <p:spPr>
+          <a:xfrm>
+            <a:off x="0" y="0"/>
+            <a:ext cx="2971800" cy="457200"/>
+          </a:xfrm>
+          <a:prstGeom prst="rect">
+            <a:avLst/>
+          </a:prstGeom>
+        </p:spPr>
+        <p:txBody>
+          <a:bodyPr vert="horz" lIns="91440" tIns="45720" rIns="91440" bIns="45720" rtlCol="0"/>
+          <a:lstStyle>
+            <a:lvl1pPr algn="l">
+              <a:defRPr sz="1200"/>
+            </a:lvl1pPr>
+          </a:lstStyle>
+          <a:p>
+            <a:endParaRPr lang="en-US"/>
+          </a:p>
+        </p:txBody>
+      </p:sp>
+      <p:sp>
+        <p:nvSpPr>
+          <p:cNvPr id="3" name="Date Placeholder 2"/>
+          <p:cNvSpPr>
+            <a:spLocks noGrp="1"/>
+          </p:cNvSpPr>
+          <p:nvPr>
+            <p:ph type="dt" idx="1"/>
+          </p:nvPr>
+        </p:nvSpPr>
+        <p:spPr>
+          <a:xfrm>
+            <a:off x="3884613" y="0"/>
+            <a:ext cx="2971800" cy="457200"/>
+          </a:xfrm>
+          <a:prstGeom prst="rect">
+            <a:avLst/>
+          </a:prstGeom>
+        </p:spPr>
+        <p:txBody>
+          <a:bodyPr vert="horz" lIns="91440" tIns="45720" rIns="91440" bIns="45720" rtlCol="0"/>
+          <a:lstStyle>
+            <a:lvl1pPr algn="r">
+              <a:defRPr sz="1200"/>
+            </a:lvl1pPr>
+          </a:lstStyle>
+          <a:p>
+            <a:fld id="{0F89C1C7-3DCD-1040-A9CF-14679D8B5DDD}" type="datetimeFigureOut">
+              <a:rPr lang="en-US" smtClean="0"/>
+              <a:t>10/17/16</a:t>
+            </a:fld>
+            <a:endParaRPr lang="en-US"/>
+          </a:p>
+        </p:txBody>
+      </p:sp>
+      <p:sp>
+        <p:nvSpPr>
+          <p:cNvPr id="4" name="Slide Image Placeholder 3"/>
+          <p:cNvSpPr>
+            <a:spLocks noGrp="1" noRot="1" noChangeAspect="1"/>
+          </p:cNvSpPr>
+          <p:nvPr>
+            <p:ph type="sldImg" idx="2"/>
+          </p:nvPr>
+        </p:nvSpPr>
+        <p:spPr>
+          <a:xfrm>
+            <a:off x="1143000" y="685800"/>
+            <a:ext cx="4572000" cy="3429000"/>
+          </a:xfrm>
+          <a:prstGeom prst="rect">
+            <a:avLst/>
+          </a:prstGeom>
+          <a:noFill/>
+          <a:ln w="12700">
+            <a:solidFill>
+              <a:prstClr val="black"/>
+            </a:solidFill>
+          </a:ln>
+        </p:spPr>
+        <p:txBody>
+          <a:bodyPr vert="horz" lIns="91440" tIns="45720" rIns="91440" bIns="45720" rtlCol="0" anchor="ctr"/>
+          <a:lstStyle/>
+          <a:p>
+            <a:endParaRPr lang="en-US"/>
+          </a:p>
+        </p:txBody>
+      </p:sp>
+      <p:sp>
+        <p:nvSpPr>
+          <p:cNvPr id="5" name="Notes Placeholder 4"/>
+          <p:cNvSpPr>
+            <a:spLocks noGrp="1"/>
+          </p:cNvSpPr>
+          <p:nvPr>
+            <p:ph type="body" sz="quarter" idx="3"/>
+          </p:nvPr>
+        </p:nvSpPr>
+        <p:spPr>
+          <a:xfrm>
+            <a:off x="685800" y="4343400"/>
+            <a:ext cx="5486400" cy="4114800"/>
+          </a:xfrm>
+          <a:prstGeom prst="rect">
+            <a:avLst/>
+          </a:prstGeom>
+        </p:spPr>
+        <p:txBody>
+          <a:bodyPr vert="horz" lIns="91440" tIns="45720" rIns="91440" bIns="45720" rtlCol="0"/>
+          <a:lstStyle/>
+          <a:p>
+            <a:pPr lvl="0"/>
+            <a:r>
+              <a:rPr lang="en-US" smtClean="0"/>
+              <a:t>Click to edit Master text styles</a:t>
+            </a:r>
+          </a:p>
+          <a:p>
+            <a:pPr lvl="1"/>
+            <a:r>
+              <a:rPr lang="en-US" smtClean="0"/>
+              <a:t>Second level</a:t>
+            </a:r>
+          </a:p>
+          <a:p>
+            <a:pPr lvl="2"/>
+            <a:r>
+              <a:rPr lang="en-US" smtClean="0"/>
+              <a:t>Third level</a:t>
+            </a:r>
+          </a:p>
+          <a:p>
+            <a:pPr lvl="3"/>
+            <a:r>
+              <a:rPr lang="en-US" smtClean="0"/>
+              <a:t>Fourth level</a:t>
+            </a:r>
+          </a:p>
+          <a:p>
+            <a:pPr lvl="4"/>
+            <a:r>
+              <a:rPr lang="en-US" smtClean="0"/>
+              <a:t>Fifth level</a:t>
+            </a:r>
+            <a:endParaRPr lang="en-US"/>
+          </a:p>
+        </p:txBody>
+      </p:sp>
+      <p:sp>
+        <p:nvSpPr>
+          <p:cNvPr id="6" name="Footer Placeholder 5"/>
+          <p:cNvSpPr>
+            <a:spLocks noGrp="1"/>
+          </p:cNvSpPr>
+          <p:nvPr>
+            <p:ph type="ftr" sz="quarter" idx="4"/>
+          </p:nvPr>
+        </p:nvSpPr>
+        <p:spPr>
+          <a:xfrm>
+            <a:off x="0" y="8685213"/>
+            <a:ext cx="2971800" cy="457200"/>
+          </a:xfrm>
+          <a:prstGeom prst="rect">
+            <a:avLst/>
+          </a:prstGeom>
+        </p:spPr>
+        <p:txBody>
+          <a:bodyPr vert="horz" lIns="91440" tIns="45720" rIns="91440" bIns="45720" rtlCol="0" anchor="b"/>
+          <a:lstStyle>
+            <a:lvl1pPr algn="l">
+              <a:defRPr sz="1200"/>
+            </a:lvl1pPr>
+          </a:lstStyle>
+          <a:p>
+            <a:endParaRPr lang="en-US"/>
+          </a:p>
+        </p:txBody>
+      </p:sp>
+      <p:sp>
+        <p:nvSpPr>
+          <p:cNvPr id="7" name="Slide Number Placeholder 6"/>
+          <p:cNvSpPr>
+            <a:spLocks noGrp="1"/>
+          </p:cNvSpPr>
+          <p:nvPr>
+            <p:ph type="sldNum" sz="quarter" idx="5"/>
+          </p:nvPr>
+        </p:nvSpPr>
+        <p:spPr>
+          <a:xfrm>
+            <a:off x="3884613" y="8685213"/>
+            <a:ext cx="2971800" cy="457200"/>
+          </a:xfrm>
+          <a:prstGeom prst="rect">
+            <a:avLst/>
+          </a:prstGeom>
+        </p:spPr>
+        <p:txBody>
+          <a:bodyPr vert="horz" lIns="91440" tIns="45720" rIns="91440" bIns="45720" rtlCol="0" anchor="b"/>
+          <a:lstStyle>
+            <a:lvl1pPr algn="r">
+              <a:defRPr sz="1200"/>
+            </a:lvl1pPr>
+          </a:lstStyle>
+          <a:p>
+            <a:fld id="{BB5E49A5-4136-284D-997B-48E1D791AD67}" type="slidenum">
+              <a:rPr lang="en-US" smtClean="0"/>
+              <a:t>‹#›</a:t>
+            </a:fld>
+            <a:endParaRPr lang="en-US"/>
+          </a:p>
+        </p:txBody>
+      </p:sp>
     </p:spTree>
     <p:extLst>
       <p:ext uri="{BB962C8B-B14F-4D97-AF65-F5344CB8AC3E}">
-        <p14:creationId xmlns:p14="http://schemas.microsoft.com/office/powerpoint/2010/main" val="2506209355"/>
+        <p14:creationId xmlns:p14="http://schemas.microsoft.com/office/powerpoint/2010/main" val="2623252185"/>
       </p:ext>
     </p:extLst>
   </p:cSld>
   <p:clrMap bg1="lt1" tx1="dk1" bg2="lt2" tx2="dk2" accent1="accent1" accent2="accent2" accent3="accent3" accent4="accent4" accent5="accent5" accent6="accent6" hlink="hlink" folHlink="folHlink"/>
   <p:notesStyle>
-    <a:lvl1pPr marL="0" algn="l" defTabSz="914400" rtl="0" eaLnBrk="1" latinLnBrk="0" hangingPunct="1">
+    <a:lvl1pPr marL="0" algn="l" defTabSz="457200" rtl="0" eaLnBrk="1" latinLnBrk="0" hangingPunct="1">
       <a:defRPr sz="1200" kern="1200">
         <a:solidFill>
           <a:schemeClr val="tx1"/>
@@ -242,7 +388,7 @@
         <a:cs typeface="+mn-cs"/>
       </a:defRPr>
     </a:lvl1pPr>
-    <a:lvl2pPr marL="457200" algn="l" defTabSz="914400" rtl="0" eaLnBrk="1" latinLnBrk="0" hangingPunct="1">
+    <a:lvl2pPr marL="457200" algn="l" defTabSz="457200" rtl="0" eaLnBrk="1" latinLnBrk="0" hangingPunct="1">
       <a:defRPr sz="1200" kern="1200">
         <a:solidFill>
           <a:schemeClr val="tx1"/>
@@ -252,7 +398,7 @@
         <a:cs typeface="+mn-cs"/>
       </a:defRPr>
     </a:lvl2pPr>
-    <a:lvl3pPr marL="914400" algn="l" defTabSz="914400" rtl="0" eaLnBrk="1" latinLnBrk="0" hangingPunct="1">
+    <a:lvl3pPr marL="914400" algn="l" defTabSz="457200" rtl="0" eaLnBrk="1" latinLnBrk="0" hangingPunct="1">
       <a:defRPr sz="1200" kern="1200">
         <a:solidFill>
           <a:schemeClr val="tx1"/>
@@ -262,7 +408,7 @@
         <a:cs typeface="+mn-cs"/>
       </a:defRPr>
     </a:lvl3pPr>
-    <a:lvl4pPr marL="1371600" algn="l" defTabSz="914400" rtl="0" eaLnBrk="1" latinLnBrk="0" hangingPunct="1">
+    <a:lvl4pPr marL="1371600" algn="l" defTabSz="457200" rtl="0" eaLnBrk="1" latinLnBrk="0" hangingPunct="1">
       <a:defRPr sz="1200" kern="1200">
         <a:solidFill>
           <a:schemeClr val="tx1"/>
@@ -272,7 +418,7 @@
         <a:cs typeface="+mn-cs"/>
       </a:defRPr>
     </a:lvl4pPr>
-    <a:lvl5pPr marL="1828800" algn="l" defTabSz="914400" rtl="0" eaLnBrk="1" latinLnBrk="0" hangingPunct="1">
+    <a:lvl5pPr marL="1828800" algn="l" defTabSz="457200" rtl="0" eaLnBrk="1" latinLnBrk="0" hangingPunct="1">
       <a:defRPr sz="1200" kern="1200">
         <a:solidFill>
           <a:schemeClr val="tx1"/>
@@ -282,7 +428,7 @@
         <a:cs typeface="+mn-cs"/>
       </a:defRPr>
     </a:lvl5pPr>
-    <a:lvl6pPr marL="2286000" algn="l" defTabSz="914400" rtl="0" eaLnBrk="1" latinLnBrk="0" hangingPunct="1">
+    <a:lvl6pPr marL="2286000" algn="l" defTabSz="457200" rtl="0" eaLnBrk="1" latinLnBrk="0" hangingPunct="1">
       <a:defRPr sz="1200" kern="1200">
         <a:solidFill>
           <a:schemeClr val="tx1"/>
@@ -292,7 +438,7 @@
         <a:cs typeface="+mn-cs"/>
       </a:defRPr>
     </a:lvl6pPr>
-    <a:lvl7pPr marL="2743200" algn="l" defTabSz="914400" rtl="0" eaLnBrk="1" latinLnBrk="0" hangingPunct="1">
+    <a:lvl7pPr marL="2743200" algn="l" defTabSz="457200" rtl="0" eaLnBrk="1" latinLnBrk="0" hangingPunct="1">
       <a:defRPr sz="1200" kern="1200">
         <a:solidFill>
           <a:schemeClr val="tx1"/>
@@ -302,7 +448,7 @@
         <a:cs typeface="+mn-cs"/>
       </a:defRPr>
     </a:lvl7pPr>
-    <a:lvl8pPr marL="3200400" algn="l" defTabSz="914400" rtl="0" eaLnBrk="1" latinLnBrk="0" hangingPunct="1">
+    <a:lvl8pPr marL="3200400" algn="l" defTabSz="457200" rtl="0" eaLnBrk="1" latinLnBrk="0" hangingPunct="1">
       <a:defRPr sz="1200" kern="1200">
         <a:solidFill>
           <a:schemeClr val="tx1"/>
@@ -312,7 +458,7 @@
         <a:cs typeface="+mn-cs"/>
       </a:defRPr>
     </a:lvl8pPr>
-    <a:lvl9pPr marL="3657600" algn="l" defTabSz="914400" rtl="0" eaLnBrk="1" latinLnBrk="0" hangingPunct="1">
+    <a:lvl9pPr marL="3657600" algn="l" defTabSz="457200" rtl="0" eaLnBrk="1" latinLnBrk="0" hangingPunct="1">
       <a:defRPr sz="1200" kern="1200">
         <a:solidFill>
           <a:schemeClr val="tx1"/>
@@ -327,7 +473,7 @@
 </file>
 
 <file path=ppt/notesSlides/notesSlide1.xml><?xml version="1.0" encoding="utf-8"?>
-<p:notes xmlns:a="http://schemas.openxmlformats.org/drawingml/2006/main" xmlns:r="http://schemas.openxmlformats.org/officeDocument/2006/relationships" xmlns:p="http://schemas.openxmlformats.org/presentationml/2006/main">
+<p:notes xmlns:a="http://schemas.openxmlformats.org/drawingml/2006/main" xmlns:p="http://schemas.openxmlformats.org/presentationml/2006/main" xmlns:r="http://schemas.openxmlformats.org/officeDocument/2006/relationships">
   <p:cSld>
     <p:spTree>
       <p:nvGrpSpPr>
@@ -347,7 +493,7 @@
         <p:nvSpPr>
           <p:cNvPr id="2" name="Slide Image Placeholder 1"/>
           <p:cNvSpPr>
-            <a:spLocks noGrp="1" noRot="1" noChangeAspect="1"/>
+            <a:spLocks noGrp="1"/>
           </p:cNvSpPr>
           <p:nvPr>
             <p:ph type="sldImg" idx="2"/>
@@ -362,7 +508,7 @@
             <a:spLocks noGrp="1"/>
           </p:cNvSpPr>
           <p:nvPr>
-            <p:ph type="body" sz="quarter" idx="3"/>
+            <p:ph type="body" idx="3" sz="quarter"/>
           </p:nvPr>
         </p:nvSpPr>
         <p:spPr/>
@@ -383,7 +529,7 @@
             <a:spLocks noGrp="1"/>
           </p:cNvSpPr>
           <p:nvPr>
-            <p:ph type="sldNum" sz="quarter" idx="5"/>
+            <p:ph type="sldNum" idx="5" sz="quarter"/>
           </p:nvPr>
         </p:nvSpPr>
         <p:spPr/>
@@ -397,7 +543,7 @@
 </file>
 
 <file path=ppt/notesSlides/notesSlide10.xml><?xml version="1.0" encoding="utf-8"?>
-<p:notes xmlns:a="http://schemas.openxmlformats.org/drawingml/2006/main" xmlns:r="http://schemas.openxmlformats.org/officeDocument/2006/relationships" xmlns:p="http://schemas.openxmlformats.org/presentationml/2006/main">
+<p:notes xmlns:a="http://schemas.openxmlformats.org/drawingml/2006/main" xmlns:p="http://schemas.openxmlformats.org/presentationml/2006/main" xmlns:r="http://schemas.openxmlformats.org/officeDocument/2006/relationships">
   <p:cSld>
     <p:spTree>
       <p:nvGrpSpPr>
@@ -417,7 +563,7 @@
         <p:nvSpPr>
           <p:cNvPr id="2" name="Slide Image Placeholder 1"/>
           <p:cNvSpPr>
-            <a:spLocks noGrp="1" noRot="1" noChangeAspect="1"/>
+            <a:spLocks noGrp="1"/>
           </p:cNvSpPr>
           <p:nvPr>
             <p:ph type="sldImg" idx="2"/>
@@ -432,7 +578,7 @@
             <a:spLocks noGrp="1"/>
           </p:cNvSpPr>
           <p:nvPr>
-            <p:ph type="body" sz="quarter" idx="3"/>
+            <p:ph type="body" idx="3" sz="quarter"/>
           </p:nvPr>
         </p:nvSpPr>
         <p:spPr/>
@@ -453,7 +599,7 @@
             <a:spLocks noGrp="1"/>
           </p:cNvSpPr>
           <p:nvPr>
-            <p:ph type="sldNum" sz="quarter" idx="5"/>
+            <p:ph type="sldNum" idx="5" sz="quarter"/>
           </p:nvPr>
         </p:nvSpPr>
         <p:spPr/>
@@ -467,7 +613,7 @@
 </file>
 
 <file path=ppt/notesSlides/notesSlide11.xml><?xml version="1.0" encoding="utf-8"?>
-<p:notes xmlns:a="http://schemas.openxmlformats.org/drawingml/2006/main" xmlns:r="http://schemas.openxmlformats.org/officeDocument/2006/relationships" xmlns:p="http://schemas.openxmlformats.org/presentationml/2006/main">
+<p:notes xmlns:a="http://schemas.openxmlformats.org/drawingml/2006/main" xmlns:p="http://schemas.openxmlformats.org/presentationml/2006/main" xmlns:r="http://schemas.openxmlformats.org/officeDocument/2006/relationships">
   <p:cSld>
     <p:spTree>
       <p:nvGrpSpPr>
@@ -487,7 +633,7 @@
         <p:nvSpPr>
           <p:cNvPr id="2" name="Slide Image Placeholder 1"/>
           <p:cNvSpPr>
-            <a:spLocks noGrp="1" noRot="1" noChangeAspect="1"/>
+            <a:spLocks noGrp="1"/>
           </p:cNvSpPr>
           <p:nvPr>
             <p:ph type="sldImg" idx="2"/>
@@ -502,7 +648,7 @@
             <a:spLocks noGrp="1"/>
           </p:cNvSpPr>
           <p:nvPr>
-            <p:ph type="body" sz="quarter" idx="3"/>
+            <p:ph type="body" idx="3" sz="quarter"/>
           </p:nvPr>
         </p:nvSpPr>
         <p:spPr/>
@@ -523,7 +669,7 @@
             <a:spLocks noGrp="1"/>
           </p:cNvSpPr>
           <p:nvPr>
-            <p:ph type="sldNum" sz="quarter" idx="5"/>
+            <p:ph type="sldNum" idx="5" sz="quarter"/>
           </p:nvPr>
         </p:nvSpPr>
         <p:spPr/>
@@ -537,7 +683,7 @@
 </file>
 
 <file path=ppt/notesSlides/notesSlide12.xml><?xml version="1.0" encoding="utf-8"?>
-<p:notes xmlns:a="http://schemas.openxmlformats.org/drawingml/2006/main" xmlns:r="http://schemas.openxmlformats.org/officeDocument/2006/relationships" xmlns:p="http://schemas.openxmlformats.org/presentationml/2006/main">
+<p:notes xmlns:a="http://schemas.openxmlformats.org/drawingml/2006/main" xmlns:p="http://schemas.openxmlformats.org/presentationml/2006/main" xmlns:r="http://schemas.openxmlformats.org/officeDocument/2006/relationships">
   <p:cSld>
     <p:spTree>
       <p:nvGrpSpPr>
@@ -557,7 +703,7 @@
         <p:nvSpPr>
           <p:cNvPr id="2" name="Slide Image Placeholder 1"/>
           <p:cNvSpPr>
-            <a:spLocks noGrp="1" noRot="1" noChangeAspect="1"/>
+            <a:spLocks noGrp="1"/>
           </p:cNvSpPr>
           <p:nvPr>
             <p:ph type="sldImg" idx="2"/>
@@ -572,7 +718,7 @@
             <a:spLocks noGrp="1"/>
           </p:cNvSpPr>
           <p:nvPr>
-            <p:ph type="body" sz="quarter" idx="3"/>
+            <p:ph type="body" idx="3" sz="quarter"/>
           </p:nvPr>
         </p:nvSpPr>
         <p:spPr/>
@@ -593,7 +739,7 @@
             <a:spLocks noGrp="1"/>
           </p:cNvSpPr>
           <p:nvPr>
-            <p:ph type="sldNum" sz="quarter" idx="5"/>
+            <p:ph type="sldNum" idx="5" sz="quarter"/>
           </p:nvPr>
         </p:nvSpPr>
         <p:spPr/>
@@ -607,7 +753,7 @@
 </file>
 
 <file path=ppt/notesSlides/notesSlide13.xml><?xml version="1.0" encoding="utf-8"?>
-<p:notes xmlns:a="http://schemas.openxmlformats.org/drawingml/2006/main" xmlns:r="http://schemas.openxmlformats.org/officeDocument/2006/relationships" xmlns:p="http://schemas.openxmlformats.org/presentationml/2006/main">
+<p:notes xmlns:a="http://schemas.openxmlformats.org/drawingml/2006/main" xmlns:p="http://schemas.openxmlformats.org/presentationml/2006/main" xmlns:r="http://schemas.openxmlformats.org/officeDocument/2006/relationships">
   <p:cSld>
     <p:spTree>
       <p:nvGrpSpPr>
@@ -627,7 +773,7 @@
         <p:nvSpPr>
           <p:cNvPr id="2" name="Slide Image Placeholder 1"/>
           <p:cNvSpPr>
-            <a:spLocks noGrp="1" noRot="1" noChangeAspect="1"/>
+            <a:spLocks noGrp="1"/>
           </p:cNvSpPr>
           <p:nvPr>
             <p:ph type="sldImg" idx="2"/>
@@ -642,7 +788,7 @@
             <a:spLocks noGrp="1"/>
           </p:cNvSpPr>
           <p:nvPr>
-            <p:ph type="body" sz="quarter" idx="3"/>
+            <p:ph type="body" idx="3" sz="quarter"/>
           </p:nvPr>
         </p:nvSpPr>
         <p:spPr/>
@@ -663,7 +809,7 @@
             <a:spLocks noGrp="1"/>
           </p:cNvSpPr>
           <p:nvPr>
-            <p:ph type="sldNum" sz="quarter" idx="5"/>
+            <p:ph type="sldNum" idx="5" sz="quarter"/>
           </p:nvPr>
         </p:nvSpPr>
         <p:spPr/>
@@ -677,7 +823,7 @@
 </file>
 
 <file path=ppt/notesSlides/notesSlide14.xml><?xml version="1.0" encoding="utf-8"?>
-<p:notes xmlns:a="http://schemas.openxmlformats.org/drawingml/2006/main" xmlns:r="http://schemas.openxmlformats.org/officeDocument/2006/relationships" xmlns:p="http://schemas.openxmlformats.org/presentationml/2006/main">
+<p:notes xmlns:a="http://schemas.openxmlformats.org/drawingml/2006/main" xmlns:p="http://schemas.openxmlformats.org/presentationml/2006/main" xmlns:r="http://schemas.openxmlformats.org/officeDocument/2006/relationships">
   <p:cSld>
     <p:spTree>
       <p:nvGrpSpPr>
@@ -697,7 +843,7 @@
         <p:nvSpPr>
           <p:cNvPr id="2" name="Slide Image Placeholder 1"/>
           <p:cNvSpPr>
-            <a:spLocks noGrp="1" noRot="1" noChangeAspect="1"/>
+            <a:spLocks noGrp="1"/>
           </p:cNvSpPr>
           <p:nvPr>
             <p:ph type="sldImg" idx="2"/>
@@ -712,7 +858,7 @@
             <a:spLocks noGrp="1"/>
           </p:cNvSpPr>
           <p:nvPr>
-            <p:ph type="body" sz="quarter" idx="3"/>
+            <p:ph type="body" idx="3" sz="quarter"/>
           </p:nvPr>
         </p:nvSpPr>
         <p:spPr/>
@@ -721,7 +867,6 @@
           <a:lstStyle/>
           <a:p>
             <a:r>
-              <a:rPr dirty="0"/>
               <a:t>For our initial implementation, we have successfully developed the working software prototype and simulation dashboard. Current progress includes the UI and simulated health visualization. We are actively progressing on real dataset preprocessing, health-relative feature extraction, ML comparison, and hardware integration.</a:t>
             </a:r>
           </a:p>
@@ -734,7 +879,7 @@
             <a:spLocks noGrp="1"/>
           </p:cNvSpPr>
           <p:nvPr>
-            <p:ph type="sldNum" sz="quarter" idx="5"/>
+            <p:ph type="sldNum" idx="5" sz="quarter"/>
           </p:nvPr>
         </p:nvSpPr>
         <p:spPr/>
@@ -748,7 +893,7 @@
 </file>
 
 <file path=ppt/notesSlides/notesSlide15.xml><?xml version="1.0" encoding="utf-8"?>
-<p:notes xmlns:a="http://schemas.openxmlformats.org/drawingml/2006/main" xmlns:r="http://schemas.openxmlformats.org/officeDocument/2006/relationships" xmlns:p="http://schemas.openxmlformats.org/presentationml/2006/main">
+<p:notes xmlns:a="http://schemas.openxmlformats.org/drawingml/2006/main" xmlns:p="http://schemas.openxmlformats.org/presentationml/2006/main" xmlns:r="http://schemas.openxmlformats.org/officeDocument/2006/relationships">
   <p:cSld>
     <p:spTree>
       <p:nvGrpSpPr>
@@ -768,7 +913,7 @@
         <p:nvSpPr>
           <p:cNvPr id="2" name="Slide Image Placeholder 1"/>
           <p:cNvSpPr>
-            <a:spLocks noGrp="1" noRot="1" noChangeAspect="1"/>
+            <a:spLocks noGrp="1"/>
           </p:cNvSpPr>
           <p:nvPr>
             <p:ph type="sldImg" idx="2"/>
@@ -783,7 +928,7 @@
             <a:spLocks noGrp="1"/>
           </p:cNvSpPr>
           <p:nvPr>
-            <p:ph type="body" sz="quarter" idx="3"/>
+            <p:ph type="body" idx="3" sz="quarter"/>
           </p:nvPr>
         </p:nvSpPr>
         <p:spPr/>
@@ -804,7 +949,7 @@
             <a:spLocks noGrp="1"/>
           </p:cNvSpPr>
           <p:nvPr>
-            <p:ph type="sldNum" sz="quarter" idx="5"/>
+            <p:ph type="sldNum" idx="5" sz="quarter"/>
           </p:nvPr>
         </p:nvSpPr>
         <p:spPr/>
@@ -818,7 +963,7 @@
 </file>
 
 <file path=ppt/notesSlides/notesSlide16.xml><?xml version="1.0" encoding="utf-8"?>
-<p:notes xmlns:a="http://schemas.openxmlformats.org/drawingml/2006/main" xmlns:r="http://schemas.openxmlformats.org/officeDocument/2006/relationships" xmlns:p="http://schemas.openxmlformats.org/presentationml/2006/main">
+<p:notes xmlns:a="http://schemas.openxmlformats.org/drawingml/2006/main" xmlns:p="http://schemas.openxmlformats.org/presentationml/2006/main" xmlns:r="http://schemas.openxmlformats.org/officeDocument/2006/relationships">
   <p:cSld>
     <p:spTree>
       <p:nvGrpSpPr>
@@ -838,7 +983,7 @@
         <p:nvSpPr>
           <p:cNvPr id="2" name="Slide Image Placeholder 1"/>
           <p:cNvSpPr>
-            <a:spLocks noGrp="1" noRot="1" noChangeAspect="1"/>
+            <a:spLocks noGrp="1"/>
           </p:cNvSpPr>
           <p:nvPr>
             <p:ph type="sldImg" idx="2"/>
@@ -853,7 +998,7 @@
             <a:spLocks noGrp="1"/>
           </p:cNvSpPr>
           <p:nvPr>
-            <p:ph type="body" sz="quarter" idx="3"/>
+            <p:ph type="body" idx="3" sz="quarter"/>
           </p:nvPr>
         </p:nvSpPr>
         <p:spPr/>
@@ -874,7 +1019,7 @@
             <a:spLocks noGrp="1"/>
           </p:cNvSpPr>
           <p:nvPr>
-            <p:ph type="sldNum" sz="quarter" idx="5"/>
+            <p:ph type="sldNum" idx="5" sz="quarter"/>
           </p:nvPr>
         </p:nvSpPr>
         <p:spPr/>
@@ -888,7 +1033,7 @@
 </file>
 
 <file path=ppt/notesSlides/notesSlide2.xml><?xml version="1.0" encoding="utf-8"?>
-<p:notes xmlns:a="http://schemas.openxmlformats.org/drawingml/2006/main" xmlns:r="http://schemas.openxmlformats.org/officeDocument/2006/relationships" xmlns:p="http://schemas.openxmlformats.org/presentationml/2006/main">
+<p:notes xmlns:a="http://schemas.openxmlformats.org/drawingml/2006/main" xmlns:p="http://schemas.openxmlformats.org/presentationml/2006/main" xmlns:r="http://schemas.openxmlformats.org/officeDocument/2006/relationships">
   <p:cSld>
     <p:spTree>
       <p:nvGrpSpPr>
@@ -908,7 +1053,7 @@
         <p:nvSpPr>
           <p:cNvPr id="2" name="Slide Image Placeholder 1"/>
           <p:cNvSpPr>
-            <a:spLocks noGrp="1" noRot="1" noChangeAspect="1"/>
+            <a:spLocks noGrp="1"/>
           </p:cNvSpPr>
           <p:nvPr>
             <p:ph type="sldImg" idx="2"/>
@@ -923,7 +1068,7 @@
             <a:spLocks noGrp="1"/>
           </p:cNvSpPr>
           <p:nvPr>
-            <p:ph type="body" sz="quarter" idx="3"/>
+            <p:ph type="body" idx="3" sz="quarter"/>
           </p:nvPr>
         </p:nvSpPr>
         <p:spPr/>
@@ -944,7 +1089,7 @@
             <a:spLocks noGrp="1"/>
           </p:cNvSpPr>
           <p:nvPr>
-            <p:ph type="sldNum" sz="quarter" idx="5"/>
+            <p:ph type="sldNum" idx="5" sz="quarter"/>
           </p:nvPr>
         </p:nvSpPr>
         <p:spPr/>
@@ -958,7 +1103,7 @@
 </file>
 
 <file path=ppt/notesSlides/notesSlide3.xml><?xml version="1.0" encoding="utf-8"?>
-<p:notes xmlns:a="http://schemas.openxmlformats.org/drawingml/2006/main" xmlns:r="http://schemas.openxmlformats.org/officeDocument/2006/relationships" xmlns:p="http://schemas.openxmlformats.org/presentationml/2006/main">
+<p:notes xmlns:a="http://schemas.openxmlformats.org/drawingml/2006/main" xmlns:p="http://schemas.openxmlformats.org/presentationml/2006/main" xmlns:r="http://schemas.openxmlformats.org/officeDocument/2006/relationships">
   <p:cSld>
     <p:spTree>
       <p:nvGrpSpPr>
@@ -978,7 +1123,7 @@
         <p:nvSpPr>
           <p:cNvPr id="2" name="Slide Image Placeholder 1"/>
           <p:cNvSpPr>
-            <a:spLocks noGrp="1" noRot="1" noChangeAspect="1"/>
+            <a:spLocks noGrp="1"/>
           </p:cNvSpPr>
           <p:nvPr>
             <p:ph type="sldImg" idx="2"/>
@@ -993,7 +1138,7 @@
             <a:spLocks noGrp="1"/>
           </p:cNvSpPr>
           <p:nvPr>
-            <p:ph type="body" sz="quarter" idx="3"/>
+            <p:ph type="body" idx="3" sz="quarter"/>
           </p:nvPr>
         </p:nvSpPr>
         <p:spPr/>
@@ -1014,7 +1159,7 @@
             <a:spLocks noGrp="1"/>
           </p:cNvSpPr>
           <p:nvPr>
-            <p:ph type="sldNum" sz="quarter" idx="5"/>
+            <p:ph type="sldNum" idx="5" sz="quarter"/>
           </p:nvPr>
         </p:nvSpPr>
         <p:spPr/>
@@ -1028,7 +1173,7 @@
 </file>
 
 <file path=ppt/notesSlides/notesSlide4.xml><?xml version="1.0" encoding="utf-8"?>
-<p:notes xmlns:a="http://schemas.openxmlformats.org/drawingml/2006/main" xmlns:r="http://schemas.openxmlformats.org/officeDocument/2006/relationships" xmlns:p="http://schemas.openxmlformats.org/presentationml/2006/main">
+<p:notes xmlns:a="http://schemas.openxmlformats.org/drawingml/2006/main" xmlns:p="http://schemas.openxmlformats.org/presentationml/2006/main" xmlns:r="http://schemas.openxmlformats.org/officeDocument/2006/relationships">
   <p:cSld>
     <p:spTree>
       <p:nvGrpSpPr>
@@ -1048,7 +1193,7 @@
         <p:nvSpPr>
           <p:cNvPr id="2" name="Slide Image Placeholder 1"/>
           <p:cNvSpPr>
-            <a:spLocks noGrp="1" noRot="1" noChangeAspect="1"/>
+            <a:spLocks noGrp="1"/>
           </p:cNvSpPr>
           <p:nvPr>
             <p:ph type="sldImg" idx="2"/>
@@ -1063,7 +1208,7 @@
             <a:spLocks noGrp="1"/>
           </p:cNvSpPr>
           <p:nvPr>
-            <p:ph type="body" sz="quarter" idx="3"/>
+            <p:ph type="body" idx="3" sz="quarter"/>
           </p:nvPr>
         </p:nvSpPr>
         <p:spPr/>
@@ -1084,7 +1229,7 @@
             <a:spLocks noGrp="1"/>
           </p:cNvSpPr>
           <p:nvPr>
-            <p:ph type="sldNum" sz="quarter" idx="5"/>
+            <p:ph type="sldNum" idx="5" sz="quarter"/>
           </p:nvPr>
         </p:nvSpPr>
         <p:spPr/>
@@ -1098,7 +1243,7 @@
 </file>
 
 <file path=ppt/notesSlides/notesSlide5.xml><?xml version="1.0" encoding="utf-8"?>
-<p:notes xmlns:a="http://schemas.openxmlformats.org/drawingml/2006/main" xmlns:r="http://schemas.openxmlformats.org/officeDocument/2006/relationships" xmlns:p="http://schemas.openxmlformats.org/presentationml/2006/main">
+<p:notes xmlns:a="http://schemas.openxmlformats.org/drawingml/2006/main" xmlns:p="http://schemas.openxmlformats.org/presentationml/2006/main" xmlns:r="http://schemas.openxmlformats.org/officeDocument/2006/relationships">
   <p:cSld>
     <p:spTree>
       <p:nvGrpSpPr>
@@ -1118,7 +1263,7 @@
         <p:nvSpPr>
           <p:cNvPr id="2" name="Slide Image Placeholder 1"/>
           <p:cNvSpPr>
-            <a:spLocks noGrp="1" noRot="1" noChangeAspect="1"/>
+            <a:spLocks noGrp="1"/>
           </p:cNvSpPr>
           <p:nvPr>
             <p:ph type="sldImg" idx="2"/>
@@ -1133,7 +1278,7 @@
             <a:spLocks noGrp="1"/>
           </p:cNvSpPr>
           <p:nvPr>
-            <p:ph type="body" sz="quarter" idx="3"/>
+            <p:ph type="body" idx="3" sz="quarter"/>
           </p:nvPr>
         </p:nvSpPr>
         <p:spPr/>
@@ -1154,7 +1299,7 @@
             <a:spLocks noGrp="1"/>
           </p:cNvSpPr>
           <p:nvPr>
-            <p:ph type="sldNum" sz="quarter" idx="5"/>
+            <p:ph type="sldNum" idx="5" sz="quarter"/>
           </p:nvPr>
         </p:nvSpPr>
         <p:spPr/>
@@ -1168,7 +1313,7 @@
 </file>
 
 <file path=ppt/notesSlides/notesSlide6.xml><?xml version="1.0" encoding="utf-8"?>
-<p:notes xmlns:a="http://schemas.openxmlformats.org/drawingml/2006/main" xmlns:r="http://schemas.openxmlformats.org/officeDocument/2006/relationships" xmlns:p="http://schemas.openxmlformats.org/presentationml/2006/main">
+<p:notes xmlns:a="http://schemas.openxmlformats.org/drawingml/2006/main" xmlns:p="http://schemas.openxmlformats.org/presentationml/2006/main" xmlns:r="http://schemas.openxmlformats.org/officeDocument/2006/relationships">
   <p:cSld>
     <p:spTree>
       <p:nvGrpSpPr>
@@ -1188,7 +1333,7 @@
         <p:nvSpPr>
           <p:cNvPr id="2" name="Slide Image Placeholder 1"/>
           <p:cNvSpPr>
-            <a:spLocks noGrp="1" noRot="1" noChangeAspect="1"/>
+            <a:spLocks noGrp="1"/>
           </p:cNvSpPr>
           <p:nvPr>
             <p:ph type="sldImg" idx="2"/>
@@ -1203,7 +1348,7 @@
             <a:spLocks noGrp="1"/>
           </p:cNvSpPr>
           <p:nvPr>
-            <p:ph type="body" sz="quarter" idx="3"/>
+            <p:ph type="body" idx="3" sz="quarter"/>
           </p:nvPr>
         </p:nvSpPr>
         <p:spPr/>
@@ -1224,7 +1369,7 @@
             <a:spLocks noGrp="1"/>
           </p:cNvSpPr>
           <p:nvPr>
-            <p:ph type="sldNum" sz="quarter" idx="5"/>
+            <p:ph type="sldNum" idx="5" sz="quarter"/>
           </p:nvPr>
         </p:nvSpPr>
         <p:spPr/>
@@ -1238,7 +1383,7 @@
 </file>
 
 <file path=ppt/notesSlides/notesSlide7.xml><?xml version="1.0" encoding="utf-8"?>
-<p:notes xmlns:a="http://schemas.openxmlformats.org/drawingml/2006/main" xmlns:r="http://schemas.openxmlformats.org/officeDocument/2006/relationships" xmlns:p="http://schemas.openxmlformats.org/presentationml/2006/main">
+<p:notes xmlns:a="http://schemas.openxmlformats.org/drawingml/2006/main" xmlns:p="http://schemas.openxmlformats.org/presentationml/2006/main" xmlns:r="http://schemas.openxmlformats.org/officeDocument/2006/relationships">
   <p:cSld>
     <p:spTree>
       <p:nvGrpSpPr>
@@ -1258,7 +1403,7 @@
         <p:nvSpPr>
           <p:cNvPr id="2" name="Slide Image Placeholder 1"/>
           <p:cNvSpPr>
-            <a:spLocks noGrp="1" noRot="1" noChangeAspect="1"/>
+            <a:spLocks noGrp="1"/>
           </p:cNvSpPr>
           <p:nvPr>
             <p:ph type="sldImg" idx="2"/>
@@ -1273,7 +1418,7 @@
             <a:spLocks noGrp="1"/>
           </p:cNvSpPr>
           <p:nvPr>
-            <p:ph type="body" sz="quarter" idx="3"/>
+            <p:ph type="body" idx="3" sz="quarter"/>
           </p:nvPr>
         </p:nvSpPr>
         <p:spPr/>
@@ -1294,7 +1439,7 @@
             <a:spLocks noGrp="1"/>
           </p:cNvSpPr>
           <p:nvPr>
-            <p:ph type="sldNum" sz="quarter" idx="5"/>
+            <p:ph type="sldNum" idx="5" sz="quarter"/>
           </p:nvPr>
         </p:nvSpPr>
         <p:spPr/>
@@ -1308,7 +1453,7 @@
 </file>
 
 <file path=ppt/notesSlides/notesSlide8.xml><?xml version="1.0" encoding="utf-8"?>
-<p:notes xmlns:a="http://schemas.openxmlformats.org/drawingml/2006/main" xmlns:r="http://schemas.openxmlformats.org/officeDocument/2006/relationships" xmlns:p="http://schemas.openxmlformats.org/presentationml/2006/main">
+<p:notes xmlns:a="http://schemas.openxmlformats.org/drawingml/2006/main" xmlns:p="http://schemas.openxmlformats.org/presentationml/2006/main" xmlns:r="http://schemas.openxmlformats.org/officeDocument/2006/relationships">
   <p:cSld>
     <p:spTree>
       <p:nvGrpSpPr>
@@ -1328,7 +1473,7 @@
         <p:nvSpPr>
           <p:cNvPr id="2" name="Slide Image Placeholder 1"/>
           <p:cNvSpPr>
-            <a:spLocks noGrp="1" noRot="1" noChangeAspect="1"/>
+            <a:spLocks noGrp="1"/>
           </p:cNvSpPr>
           <p:nvPr>
             <p:ph type="sldImg" idx="2"/>
@@ -1343,7 +1488,7 @@
             <a:spLocks noGrp="1"/>
           </p:cNvSpPr>
           <p:nvPr>
-            <p:ph type="body" sz="quarter" idx="3"/>
+            <p:ph type="body" idx="3" sz="quarter"/>
           </p:nvPr>
         </p:nvSpPr>
         <p:spPr/>
@@ -1364,7 +1509,7 @@
             <a:spLocks noGrp="1"/>
           </p:cNvSpPr>
           <p:nvPr>
-            <p:ph type="sldNum" sz="quarter" idx="5"/>
+            <p:ph type="sldNum" idx="5" sz="quarter"/>
           </p:nvPr>
         </p:nvSpPr>
         <p:spPr/>
@@ -1378,7 +1523,7 @@
 </file>
 
 <file path=ppt/notesSlides/notesSlide9.xml><?xml version="1.0" encoding="utf-8"?>
-<p:notes xmlns:a="http://schemas.openxmlformats.org/drawingml/2006/main" xmlns:r="http://schemas.openxmlformats.org/officeDocument/2006/relationships" xmlns:p="http://schemas.openxmlformats.org/presentationml/2006/main">
+<p:notes xmlns:a="http://schemas.openxmlformats.org/drawingml/2006/main" xmlns:p="http://schemas.openxmlformats.org/presentationml/2006/main" xmlns:r="http://schemas.openxmlformats.org/officeDocument/2006/relationships">
   <p:cSld>
     <p:spTree>
       <p:nvGrpSpPr>
@@ -1398,7 +1543,7 @@
         <p:nvSpPr>
           <p:cNvPr id="2" name="Slide Image Placeholder 1"/>
           <p:cNvSpPr>
-            <a:spLocks noGrp="1" noRot="1" noChangeAspect="1"/>
+            <a:spLocks noGrp="1"/>
           </p:cNvSpPr>
           <p:nvPr>
             <p:ph type="sldImg" idx="2"/>
@@ -1413,7 +1558,7 @@
             <a:spLocks noGrp="1"/>
           </p:cNvSpPr>
           <p:nvPr>
-            <p:ph type="body" sz="quarter" idx="3"/>
+            <p:ph type="body" idx="3" sz="quarter"/>
           </p:nvPr>
         </p:nvSpPr>
         <p:spPr/>
@@ -1434,7 +1579,7 @@
             <a:spLocks noGrp="1"/>
           </p:cNvSpPr>
           <p:nvPr>
-            <p:ph type="sldNum" sz="quarter" idx="5"/>
+            <p:ph type="sldNum" idx="5" sz="quarter"/>
           </p:nvPr>
         </p:nvSpPr>
         <p:spPr/>
@@ -1485,9 +1630,10 @@
           <a:lstStyle/>
           <a:p>
             <a:r>
-              <a:rPr lang="en-US"/>
+              <a:rPr lang="en-US" smtClean="0"/>
               <a:t>Click to edit Master title style</a:t>
             </a:r>
+            <a:endParaRPr lang="en-US"/>
           </a:p>
         </p:txBody>
       </p:sp>
@@ -1603,9 +1749,10 @@
           </a:lstStyle>
           <a:p>
             <a:r>
-              <a:rPr lang="en-US"/>
+              <a:rPr lang="en-US" smtClean="0"/>
               <a:t>Click to edit Master subtitle style</a:t>
             </a:r>
+            <a:endParaRPr lang="en-US"/>
           </a:p>
         </p:txBody>
       </p:sp>
@@ -1626,7 +1773,7 @@
           <a:p>
             <a:fld id="{5BCAD085-E8A6-8845-BD4E-CB4CCA059FC4}" type="datetimeFigureOut">
               <a:rPr lang="en-US" smtClean="0"/>
-              <a:t>9/22/2026</a:t>
+              <a:t>1/27/13</a:t>
             </a:fld>
             <a:endParaRPr lang="en-US"/>
           </a:p>
@@ -1720,9 +1867,10 @@
           <a:lstStyle/>
           <a:p>
             <a:r>
-              <a:rPr lang="en-US"/>
+              <a:rPr lang="en-US" smtClean="0"/>
               <a:t>Click to edit Master title style</a:t>
             </a:r>
+            <a:endParaRPr lang="en-US"/>
           </a:p>
         </p:txBody>
       </p:sp>
@@ -1743,37 +1891,38 @@
           <a:p>
             <a:pPr lvl="0"/>
             <a:r>
-              <a:rPr lang="en-US"/>
+              <a:rPr lang="en-US" smtClean="0"/>
               <a:t>Click to edit Master text styles</a:t>
             </a:r>
           </a:p>
           <a:p>
             <a:pPr lvl="1"/>
             <a:r>
-              <a:rPr lang="en-US"/>
+              <a:rPr lang="en-US" smtClean="0"/>
               <a:t>Second level</a:t>
             </a:r>
           </a:p>
           <a:p>
             <a:pPr lvl="2"/>
             <a:r>
-              <a:rPr lang="en-US"/>
+              <a:rPr lang="en-US" smtClean="0"/>
               <a:t>Third level</a:t>
             </a:r>
           </a:p>
           <a:p>
             <a:pPr lvl="3"/>
             <a:r>
-              <a:rPr lang="en-US"/>
+              <a:rPr lang="en-US" smtClean="0"/>
               <a:t>Fourth level</a:t>
             </a:r>
           </a:p>
           <a:p>
             <a:pPr lvl="4"/>
             <a:r>
-              <a:rPr lang="en-US"/>
+              <a:rPr lang="en-US" smtClean="0"/>
               <a:t>Fifth level</a:t>
             </a:r>
+            <a:endParaRPr lang="en-US"/>
           </a:p>
         </p:txBody>
       </p:sp>
@@ -1794,7 +1943,7 @@
           <a:p>
             <a:fld id="{5BCAD085-E8A6-8845-BD4E-CB4CCA059FC4}" type="datetimeFigureOut">
               <a:rPr lang="en-US" smtClean="0"/>
-              <a:t>9/22/2026</a:t>
+              <a:t>1/27/13</a:t>
             </a:fld>
             <a:endParaRPr lang="en-US"/>
           </a:p>
@@ -1893,9 +2042,10 @@
           <a:lstStyle/>
           <a:p>
             <a:r>
-              <a:rPr lang="en-US"/>
+              <a:rPr lang="en-US" smtClean="0"/>
               <a:t>Click to edit Master title style</a:t>
             </a:r>
+            <a:endParaRPr lang="en-US"/>
           </a:p>
         </p:txBody>
       </p:sp>
@@ -1921,37 +2071,38 @@
           <a:p>
             <a:pPr lvl="0"/>
             <a:r>
-              <a:rPr lang="en-US"/>
+              <a:rPr lang="en-US" smtClean="0"/>
               <a:t>Click to edit Master text styles</a:t>
             </a:r>
           </a:p>
           <a:p>
             <a:pPr lvl="1"/>
             <a:r>
-              <a:rPr lang="en-US"/>
+              <a:rPr lang="en-US" smtClean="0"/>
               <a:t>Second level</a:t>
             </a:r>
           </a:p>
           <a:p>
             <a:pPr lvl="2"/>
             <a:r>
-              <a:rPr lang="en-US"/>
+              <a:rPr lang="en-US" smtClean="0"/>
               <a:t>Third level</a:t>
             </a:r>
           </a:p>
           <a:p>
             <a:pPr lvl="3"/>
             <a:r>
-              <a:rPr lang="en-US"/>
+              <a:rPr lang="en-US" smtClean="0"/>
               <a:t>Fourth level</a:t>
             </a:r>
           </a:p>
           <a:p>
             <a:pPr lvl="4"/>
             <a:r>
-              <a:rPr lang="en-US"/>
+              <a:rPr lang="en-US" smtClean="0"/>
               <a:t>Fifth level</a:t>
             </a:r>
+            <a:endParaRPr lang="en-US"/>
           </a:p>
         </p:txBody>
       </p:sp>
@@ -1972,7 +2123,7 @@
           <a:p>
             <a:fld id="{5BCAD085-E8A6-8845-BD4E-CB4CCA059FC4}" type="datetimeFigureOut">
               <a:rPr lang="en-US" smtClean="0"/>
-              <a:t>9/22/2026</a:t>
+              <a:t>1/27/13</a:t>
             </a:fld>
             <a:endParaRPr lang="en-US"/>
           </a:p>
@@ -2066,9 +2217,10 @@
           <a:lstStyle/>
           <a:p>
             <a:r>
-              <a:rPr lang="en-US"/>
+              <a:rPr lang="en-US" smtClean="0"/>
               <a:t>Click to edit Master title style</a:t>
             </a:r>
+            <a:endParaRPr lang="en-US"/>
           </a:p>
         </p:txBody>
       </p:sp>
@@ -2089,37 +2241,38 @@
           <a:p>
             <a:pPr lvl="0"/>
             <a:r>
-              <a:rPr lang="en-US"/>
+              <a:rPr lang="en-US" smtClean="0"/>
               <a:t>Click to edit Master text styles</a:t>
             </a:r>
           </a:p>
           <a:p>
             <a:pPr lvl="1"/>
             <a:r>
-              <a:rPr lang="en-US"/>
+              <a:rPr lang="en-US" smtClean="0"/>
               <a:t>Second level</a:t>
             </a:r>
           </a:p>
           <a:p>
             <a:pPr lvl="2"/>
             <a:r>
-              <a:rPr lang="en-US"/>
+              <a:rPr lang="en-US" smtClean="0"/>
               <a:t>Third level</a:t>
             </a:r>
           </a:p>
           <a:p>
             <a:pPr lvl="3"/>
             <a:r>
-              <a:rPr lang="en-US"/>
+              <a:rPr lang="en-US" smtClean="0"/>
               <a:t>Fourth level</a:t>
             </a:r>
           </a:p>
           <a:p>
             <a:pPr lvl="4"/>
             <a:r>
-              <a:rPr lang="en-US"/>
+              <a:rPr lang="en-US" smtClean="0"/>
               <a:t>Fifth level</a:t>
             </a:r>
+            <a:endParaRPr lang="en-US"/>
           </a:p>
         </p:txBody>
       </p:sp>
@@ -2140,7 +2293,7 @@
           <a:p>
             <a:fld id="{5BCAD085-E8A6-8845-BD4E-CB4CCA059FC4}" type="datetimeFigureOut">
               <a:rPr lang="en-US" smtClean="0"/>
-              <a:t>9/22/2026</a:t>
+              <a:t>1/27/13</a:t>
             </a:fld>
             <a:endParaRPr lang="en-US"/>
           </a:p>
@@ -2243,9 +2396,10 @@
           </a:lstStyle>
           <a:p>
             <a:r>
-              <a:rPr lang="en-US"/>
+              <a:rPr lang="en-US" smtClean="0"/>
               <a:t>Click to edit Master title style</a:t>
             </a:r>
+            <a:endParaRPr lang="en-US"/>
           </a:p>
         </p:txBody>
       </p:sp>
@@ -2362,7 +2516,7 @@
           <a:p>
             <a:pPr lvl="0"/>
             <a:r>
-              <a:rPr lang="en-US"/>
+              <a:rPr lang="en-US" smtClean="0"/>
               <a:t>Click to edit Master text styles</a:t>
             </a:r>
           </a:p>
@@ -2385,7 +2539,7 @@
           <a:p>
             <a:fld id="{5BCAD085-E8A6-8845-BD4E-CB4CCA059FC4}" type="datetimeFigureOut">
               <a:rPr lang="en-US" smtClean="0"/>
-              <a:t>9/22/2026</a:t>
+              <a:t>1/27/13</a:t>
             </a:fld>
             <a:endParaRPr lang="en-US"/>
           </a:p>
@@ -2479,9 +2633,10 @@
           <a:lstStyle/>
           <a:p>
             <a:r>
-              <a:rPr lang="en-US"/>
+              <a:rPr lang="en-US" smtClean="0"/>
               <a:t>Click to edit Master title style</a:t>
             </a:r>
+            <a:endParaRPr lang="en-US"/>
           </a:p>
         </p:txBody>
       </p:sp>
@@ -2535,37 +2690,38 @@
           <a:p>
             <a:pPr lvl="0"/>
             <a:r>
-              <a:rPr lang="en-US"/>
+              <a:rPr lang="en-US" smtClean="0"/>
               <a:t>Click to edit Master text styles</a:t>
             </a:r>
           </a:p>
           <a:p>
             <a:pPr lvl="1"/>
             <a:r>
-              <a:rPr lang="en-US"/>
+              <a:rPr lang="en-US" smtClean="0"/>
               <a:t>Second level</a:t>
             </a:r>
           </a:p>
           <a:p>
             <a:pPr lvl="2"/>
             <a:r>
-              <a:rPr lang="en-US"/>
+              <a:rPr lang="en-US" smtClean="0"/>
               <a:t>Third level</a:t>
             </a:r>
           </a:p>
           <a:p>
             <a:pPr lvl="3"/>
             <a:r>
-              <a:rPr lang="en-US"/>
+              <a:rPr lang="en-US" smtClean="0"/>
               <a:t>Fourth level</a:t>
             </a:r>
           </a:p>
           <a:p>
             <a:pPr lvl="4"/>
             <a:r>
-              <a:rPr lang="en-US"/>
+              <a:rPr lang="en-US" smtClean="0"/>
               <a:t>Fifth level</a:t>
             </a:r>
+            <a:endParaRPr lang="en-US"/>
           </a:p>
         </p:txBody>
       </p:sp>
@@ -2619,37 +2775,38 @@
           <a:p>
             <a:pPr lvl="0"/>
             <a:r>
-              <a:rPr lang="en-US"/>
+              <a:rPr lang="en-US" smtClean="0"/>
               <a:t>Click to edit Master text styles</a:t>
             </a:r>
           </a:p>
           <a:p>
             <a:pPr lvl="1"/>
             <a:r>
-              <a:rPr lang="en-US"/>
+              <a:rPr lang="en-US" smtClean="0"/>
               <a:t>Second level</a:t>
             </a:r>
           </a:p>
           <a:p>
             <a:pPr lvl="2"/>
             <a:r>
-              <a:rPr lang="en-US"/>
+              <a:rPr lang="en-US" smtClean="0"/>
               <a:t>Third level</a:t>
             </a:r>
           </a:p>
           <a:p>
             <a:pPr lvl="3"/>
             <a:r>
-              <a:rPr lang="en-US"/>
+              <a:rPr lang="en-US" smtClean="0"/>
               <a:t>Fourth level</a:t>
             </a:r>
           </a:p>
           <a:p>
             <a:pPr lvl="4"/>
             <a:r>
-              <a:rPr lang="en-US"/>
+              <a:rPr lang="en-US" smtClean="0"/>
               <a:t>Fifth level</a:t>
             </a:r>
+            <a:endParaRPr lang="en-US"/>
           </a:p>
         </p:txBody>
       </p:sp>
@@ -2670,7 +2827,7 @@
           <a:p>
             <a:fld id="{5BCAD085-E8A6-8845-BD4E-CB4CCA059FC4}" type="datetimeFigureOut">
               <a:rPr lang="en-US" smtClean="0"/>
-              <a:t>9/22/2026</a:t>
+              <a:t>1/27/13</a:t>
             </a:fld>
             <a:endParaRPr lang="en-US"/>
           </a:p>
@@ -2768,9 +2925,10 @@
           </a:lstStyle>
           <a:p>
             <a:r>
-              <a:rPr lang="en-US"/>
+              <a:rPr lang="en-US" smtClean="0"/>
               <a:t>Click to edit Master title style</a:t>
             </a:r>
+            <a:endParaRPr lang="en-US"/>
           </a:p>
         </p:txBody>
       </p:sp>
@@ -2833,7 +2991,7 @@
           <a:p>
             <a:pPr lvl="0"/>
             <a:r>
-              <a:rPr lang="en-US"/>
+              <a:rPr lang="en-US" smtClean="0"/>
               <a:t>Click to edit Master text styles</a:t>
             </a:r>
           </a:p>
@@ -2889,37 +3047,38 @@
           <a:p>
             <a:pPr lvl="0"/>
             <a:r>
-              <a:rPr lang="en-US"/>
+              <a:rPr lang="en-US" smtClean="0"/>
               <a:t>Click to edit Master text styles</a:t>
             </a:r>
           </a:p>
           <a:p>
             <a:pPr lvl="1"/>
             <a:r>
-              <a:rPr lang="en-US"/>
+              <a:rPr lang="en-US" smtClean="0"/>
               <a:t>Second level</a:t>
             </a:r>
           </a:p>
           <a:p>
             <a:pPr lvl="2"/>
             <a:r>
-              <a:rPr lang="en-US"/>
+              <a:rPr lang="en-US" smtClean="0"/>
               <a:t>Third level</a:t>
             </a:r>
           </a:p>
           <a:p>
             <a:pPr lvl="3"/>
             <a:r>
-              <a:rPr lang="en-US"/>
+              <a:rPr lang="en-US" smtClean="0"/>
               <a:t>Fourth level</a:t>
             </a:r>
           </a:p>
           <a:p>
             <a:pPr lvl="4"/>
             <a:r>
-              <a:rPr lang="en-US"/>
+              <a:rPr lang="en-US" smtClean="0"/>
               <a:t>Fifth level</a:t>
             </a:r>
+            <a:endParaRPr lang="en-US"/>
           </a:p>
         </p:txBody>
       </p:sp>
@@ -2982,7 +3141,7 @@
           <a:p>
             <a:pPr lvl="0"/>
             <a:r>
-              <a:rPr lang="en-US"/>
+              <a:rPr lang="en-US" smtClean="0"/>
               <a:t>Click to edit Master text styles</a:t>
             </a:r>
           </a:p>
@@ -3038,37 +3197,38 @@
           <a:p>
             <a:pPr lvl="0"/>
             <a:r>
-              <a:rPr lang="en-US"/>
+              <a:rPr lang="en-US" smtClean="0"/>
               <a:t>Click to edit Master text styles</a:t>
             </a:r>
           </a:p>
           <a:p>
             <a:pPr lvl="1"/>
             <a:r>
-              <a:rPr lang="en-US"/>
+              <a:rPr lang="en-US" smtClean="0"/>
               <a:t>Second level</a:t>
             </a:r>
           </a:p>
           <a:p>
             <a:pPr lvl="2"/>
             <a:r>
-              <a:rPr lang="en-US"/>
+              <a:rPr lang="en-US" smtClean="0"/>
               <a:t>Third level</a:t>
             </a:r>
           </a:p>
           <a:p>
             <a:pPr lvl="3"/>
             <a:r>
-              <a:rPr lang="en-US"/>
+              <a:rPr lang="en-US" smtClean="0"/>
               <a:t>Fourth level</a:t>
             </a:r>
           </a:p>
           <a:p>
             <a:pPr lvl="4"/>
             <a:r>
-              <a:rPr lang="en-US"/>
+              <a:rPr lang="en-US" smtClean="0"/>
               <a:t>Fifth level</a:t>
             </a:r>
+            <a:endParaRPr lang="en-US"/>
           </a:p>
         </p:txBody>
       </p:sp>
@@ -3089,7 +3249,7 @@
           <a:p>
             <a:fld id="{5BCAD085-E8A6-8845-BD4E-CB4CCA059FC4}" type="datetimeFigureOut">
               <a:rPr lang="en-US" smtClean="0"/>
-              <a:t>9/22/2026</a:t>
+              <a:t>1/27/13</a:t>
             </a:fld>
             <a:endParaRPr lang="en-US"/>
           </a:p>
@@ -3183,9 +3343,10 @@
           <a:lstStyle/>
           <a:p>
             <a:r>
-              <a:rPr lang="en-US"/>
+              <a:rPr lang="en-US" smtClean="0"/>
               <a:t>Click to edit Master title style</a:t>
             </a:r>
+            <a:endParaRPr lang="en-US"/>
           </a:p>
         </p:txBody>
       </p:sp>
@@ -3206,7 +3367,7 @@
           <a:p>
             <a:fld id="{5BCAD085-E8A6-8845-BD4E-CB4CCA059FC4}" type="datetimeFigureOut">
               <a:rPr lang="en-US" smtClean="0"/>
-              <a:t>9/22/2026</a:t>
+              <a:t>1/27/13</a:t>
             </a:fld>
             <a:endParaRPr lang="en-US"/>
           </a:p>
@@ -3301,7 +3462,7 @@
           <a:p>
             <a:fld id="{5BCAD085-E8A6-8845-BD4E-CB4CCA059FC4}" type="datetimeFigureOut">
               <a:rPr lang="en-US" smtClean="0"/>
-              <a:t>9/22/2026</a:t>
+              <a:t>1/27/13</a:t>
             </a:fld>
             <a:endParaRPr lang="en-US"/>
           </a:p>
@@ -3404,9 +3565,10 @@
           </a:lstStyle>
           <a:p>
             <a:r>
-              <a:rPr lang="en-US"/>
+              <a:rPr lang="en-US" smtClean="0"/>
               <a:t>Click to edit Master title style</a:t>
             </a:r>
+            <a:endParaRPr lang="en-US"/>
           </a:p>
         </p:txBody>
       </p:sp>
@@ -3460,37 +3622,38 @@
           <a:p>
             <a:pPr lvl="0"/>
             <a:r>
-              <a:rPr lang="en-US"/>
+              <a:rPr lang="en-US" smtClean="0"/>
               <a:t>Click to edit Master text styles</a:t>
             </a:r>
           </a:p>
           <a:p>
             <a:pPr lvl="1"/>
             <a:r>
-              <a:rPr lang="en-US"/>
+              <a:rPr lang="en-US" smtClean="0"/>
               <a:t>Second level</a:t>
             </a:r>
           </a:p>
           <a:p>
             <a:pPr lvl="2"/>
             <a:r>
-              <a:rPr lang="en-US"/>
+              <a:rPr lang="en-US" smtClean="0"/>
               <a:t>Third level</a:t>
             </a:r>
           </a:p>
           <a:p>
             <a:pPr lvl="3"/>
             <a:r>
-              <a:rPr lang="en-US"/>
+              <a:rPr lang="en-US" smtClean="0"/>
               <a:t>Fourth level</a:t>
             </a:r>
           </a:p>
           <a:p>
             <a:pPr lvl="4"/>
             <a:r>
-              <a:rPr lang="en-US"/>
+              <a:rPr lang="en-US" smtClean="0"/>
               <a:t>Fifth level</a:t>
             </a:r>
+            <a:endParaRPr lang="en-US"/>
           </a:p>
         </p:txBody>
       </p:sp>
@@ -3553,7 +3716,7 @@
           <a:p>
             <a:pPr lvl="0"/>
             <a:r>
-              <a:rPr lang="en-US"/>
+              <a:rPr lang="en-US" smtClean="0"/>
               <a:t>Click to edit Master text styles</a:t>
             </a:r>
           </a:p>
@@ -3576,7 +3739,7 @@
           <a:p>
             <a:fld id="{5BCAD085-E8A6-8845-BD4E-CB4CCA059FC4}" type="datetimeFigureOut">
               <a:rPr lang="en-US" smtClean="0"/>
-              <a:t>9/22/2026</a:t>
+              <a:t>1/27/13</a:t>
             </a:fld>
             <a:endParaRPr lang="en-US"/>
           </a:p>
@@ -3679,9 +3842,10 @@
           </a:lstStyle>
           <a:p>
             <a:r>
-              <a:rPr lang="en-US"/>
+              <a:rPr lang="en-US" smtClean="0"/>
               <a:t>Click to edit Master title style</a:t>
             </a:r>
+            <a:endParaRPr lang="en-US"/>
           </a:p>
         </p:txBody>
       </p:sp>
@@ -3805,7 +3969,7 @@
           <a:p>
             <a:pPr lvl="0"/>
             <a:r>
-              <a:rPr lang="en-US"/>
+              <a:rPr lang="en-US" smtClean="0"/>
               <a:t>Click to edit Master text styles</a:t>
             </a:r>
           </a:p>
@@ -3828,7 +3992,7 @@
           <a:p>
             <a:fld id="{5BCAD085-E8A6-8845-BD4E-CB4CCA059FC4}" type="datetimeFigureOut">
               <a:rPr lang="en-US" smtClean="0"/>
-              <a:t>9/22/2026</a:t>
+              <a:t>1/27/13</a:t>
             </a:fld>
             <a:endParaRPr lang="en-US"/>
           </a:p>
@@ -3937,9 +4101,10 @@
           <a:lstStyle/>
           <a:p>
             <a:r>
-              <a:rPr lang="en-US"/>
+              <a:rPr lang="en-US" smtClean="0"/>
               <a:t>Click to edit Master title style</a:t>
             </a:r>
+            <a:endParaRPr lang="en-US"/>
           </a:p>
         </p:txBody>
       </p:sp>
@@ -3970,37 +4135,38 @@
           <a:p>
             <a:pPr lvl="0"/>
             <a:r>
-              <a:rPr lang="en-US"/>
+              <a:rPr lang="en-US" smtClean="0"/>
               <a:t>Click to edit Master text styles</a:t>
             </a:r>
           </a:p>
           <a:p>
             <a:pPr lvl="1"/>
             <a:r>
-              <a:rPr lang="en-US"/>
+              <a:rPr lang="en-US" smtClean="0"/>
               <a:t>Second level</a:t>
             </a:r>
           </a:p>
           <a:p>
             <a:pPr lvl="2"/>
             <a:r>
-              <a:rPr lang="en-US"/>
+              <a:rPr lang="en-US" smtClean="0"/>
               <a:t>Third level</a:t>
             </a:r>
           </a:p>
           <a:p>
             <a:pPr lvl="3"/>
             <a:r>
-              <a:rPr lang="en-US"/>
+              <a:rPr lang="en-US" smtClean="0"/>
               <a:t>Fourth level</a:t>
             </a:r>
           </a:p>
           <a:p>
             <a:pPr lvl="4"/>
             <a:r>
-              <a:rPr lang="en-US"/>
+              <a:rPr lang="en-US" smtClean="0"/>
               <a:t>Fifth level</a:t>
             </a:r>
+            <a:endParaRPr lang="en-US"/>
           </a:p>
         </p:txBody>
       </p:sp>
@@ -4039,7 +4205,7 @@
           <a:p>
             <a:fld id="{5BCAD085-E8A6-8845-BD4E-CB4CCA059FC4}" type="datetimeFigureOut">
               <a:rPr lang="en-US" smtClean="0"/>
-              <a:t>9/22/2026</a:t>
+              <a:t>1/27/13</a:t>
             </a:fld>
             <a:endParaRPr lang="en-US"/>
           </a:p>
@@ -4398,7 +4564,7 @@
 </file>
 
 <file path=ppt/slides/slide1.xml><?xml version="1.0" encoding="utf-8"?>
-<p:sld xmlns:a="http://schemas.openxmlformats.org/drawingml/2006/main" xmlns:r="http://schemas.openxmlformats.org/officeDocument/2006/relationships" xmlns:p="http://schemas.openxmlformats.org/presentationml/2006/main">
+<p:sld xmlns:a="http://schemas.openxmlformats.org/drawingml/2006/main" xmlns:p="http://schemas.openxmlformats.org/presentationml/2006/main" xmlns:r="http://schemas.openxmlformats.org/officeDocument/2006/relationships">
   <p:cSld>
     <p:spTree>
       <p:nvGrpSpPr>
@@ -4406,14 +4572,7 @@
         <p:cNvGrpSpPr/>
         <p:nvPr/>
       </p:nvGrpSpPr>
-      <p:grpSpPr>
-        <a:xfrm>
-          <a:off x="0" y="0"/>
-          <a:ext cx="0" cy="0"/>
-          <a:chOff x="0" y="0"/>
-          <a:chExt cx="0" cy="0"/>
-        </a:xfrm>
-      </p:grpSpPr>
+      <p:grpSpPr/>
       <p:sp>
         <p:nvSpPr>
           <p:cNvPr id="2" name="TextBox 1"/>
@@ -4435,12 +4594,10 @@
             <a:spAutoFit/>
           </a:bodyPr>
           <a:lstStyle/>
-          <a:p>
-            <a:endParaRPr/>
-          </a:p>
+          <a:p/>
           <a:p>
             <a:pPr algn="ctr">
-              <a:defRPr sz="5400" b="1">
+              <a:defRPr b="1" sz="5400">
                 <a:solidFill>
                   <a:srgbClr val="111827"/>
                 </a:solidFill>
@@ -4473,9 +4630,7 @@
             <a:spAutoFit/>
           </a:bodyPr>
           <a:lstStyle/>
-          <a:p>
-            <a:endParaRPr/>
-          </a:p>
+          <a:p/>
           <a:p>
             <a:pPr algn="ctr">
               <a:defRPr sz="2800">
@@ -4555,7 +4710,6 @@
                 </a:solidFill>
               </a:defRPr>
             </a:pPr>
-            <a:endParaRPr/>
           </a:p>
           <a:p>
             <a:pPr>
@@ -4660,7 +4814,6 @@
                 </a:solidFill>
               </a:defRPr>
             </a:pPr>
-            <a:endParaRPr/>
           </a:p>
           <a:p>
             <a:pPr>
@@ -4709,7 +4862,7 @@
 </file>
 
 <file path=ppt/slides/slide10.xml><?xml version="1.0" encoding="utf-8"?>
-<p:sld xmlns:a="http://schemas.openxmlformats.org/drawingml/2006/main" xmlns:r="http://schemas.openxmlformats.org/officeDocument/2006/relationships" xmlns:p="http://schemas.openxmlformats.org/presentationml/2006/main">
+<p:sld xmlns:a="http://schemas.openxmlformats.org/drawingml/2006/main" xmlns:p="http://schemas.openxmlformats.org/presentationml/2006/main" xmlns:r="http://schemas.openxmlformats.org/officeDocument/2006/relationships">
   <p:cSld>
     <p:spTree>
       <p:nvGrpSpPr>
@@ -4717,14 +4870,7 @@
         <p:cNvGrpSpPr/>
         <p:nvPr/>
       </p:nvGrpSpPr>
-      <p:grpSpPr>
-        <a:xfrm>
-          <a:off x="0" y="0"/>
-          <a:ext cx="0" cy="0"/>
-          <a:chOff x="0" y="0"/>
-          <a:chExt cx="0" cy="0"/>
-        </a:xfrm>
-      </p:grpSpPr>
+      <p:grpSpPr/>
       <p:sp>
         <p:nvSpPr>
           <p:cNvPr id="2" name="TextBox 1"/>
@@ -4746,9 +4892,7 @@
             <a:spAutoFit/>
           </a:bodyPr>
           <a:lstStyle/>
-          <a:p>
-            <a:endParaRPr/>
-          </a:p>
+          <a:p/>
           <a:p>
             <a:pPr>
               <a:defRPr sz="1000">
@@ -4784,12 +4928,10 @@
             <a:spAutoFit/>
           </a:bodyPr>
           <a:lstStyle/>
-          <a:p>
-            <a:endParaRPr/>
-          </a:p>
-          <a:p>
-            <a:pPr>
-              <a:defRPr sz="3600" b="1">
+          <a:p/>
+          <a:p>
+            <a:pPr>
+              <a:defRPr b="1" sz="3600">
                 <a:solidFill>
                   <a:srgbClr val="111827"/>
                 </a:solidFill>
@@ -4822,9 +4964,7 @@
             <a:spAutoFit/>
           </a:bodyPr>
           <a:lstStyle/>
-          <a:p>
-            <a:endParaRPr/>
-          </a:p>
+          <a:p/>
           <a:p>
             <a:pPr>
               <a:spcAft>
@@ -4926,7 +5066,7 @@
 </file>
 
 <file path=ppt/slides/slide11.xml><?xml version="1.0" encoding="utf-8"?>
-<p:sld xmlns:a="http://schemas.openxmlformats.org/drawingml/2006/main" xmlns:r="http://schemas.openxmlformats.org/officeDocument/2006/relationships" xmlns:p="http://schemas.openxmlformats.org/presentationml/2006/main">
+<p:sld xmlns:a="http://schemas.openxmlformats.org/drawingml/2006/main" xmlns:p="http://schemas.openxmlformats.org/presentationml/2006/main" xmlns:r="http://schemas.openxmlformats.org/officeDocument/2006/relationships">
   <p:cSld>
     <p:spTree>
       <p:nvGrpSpPr>
@@ -4934,14 +5074,7 @@
         <p:cNvGrpSpPr/>
         <p:nvPr/>
       </p:nvGrpSpPr>
-      <p:grpSpPr>
-        <a:xfrm>
-          <a:off x="0" y="0"/>
-          <a:ext cx="0" cy="0"/>
-          <a:chOff x="0" y="0"/>
-          <a:chExt cx="0" cy="0"/>
-        </a:xfrm>
-      </p:grpSpPr>
+      <p:grpSpPr/>
       <p:sp>
         <p:nvSpPr>
           <p:cNvPr id="2" name="TextBox 1"/>
@@ -4963,9 +5096,7 @@
             <a:spAutoFit/>
           </a:bodyPr>
           <a:lstStyle/>
-          <a:p>
-            <a:endParaRPr/>
-          </a:p>
+          <a:p/>
           <a:p>
             <a:pPr>
               <a:defRPr sz="1000">
@@ -5001,12 +5132,10 @@
             <a:spAutoFit/>
           </a:bodyPr>
           <a:lstStyle/>
-          <a:p>
-            <a:endParaRPr/>
-          </a:p>
-          <a:p>
-            <a:pPr>
-              <a:defRPr sz="3600" b="1">
+          <a:p/>
+          <a:p>
+            <a:pPr>
+              <a:defRPr b="1" sz="3600">
                 <a:solidFill>
                   <a:srgbClr val="111827"/>
                 </a:solidFill>
@@ -5039,9 +5168,7 @@
             <a:spAutoFit/>
           </a:bodyPr>
           <a:lstStyle/>
-          <a:p>
-            <a:endParaRPr/>
-          </a:p>
+          <a:p/>
           <a:p>
             <a:pPr algn="ctr">
               <a:defRPr sz="1400" b="1">
@@ -5257,7 +5384,7 @@
 </file>
 
 <file path=ppt/slides/slide12.xml><?xml version="1.0" encoding="utf-8"?>
-<p:sld xmlns:a="http://schemas.openxmlformats.org/drawingml/2006/main" xmlns:r="http://schemas.openxmlformats.org/officeDocument/2006/relationships" xmlns:p="http://schemas.openxmlformats.org/presentationml/2006/main">
+<p:sld xmlns:a="http://schemas.openxmlformats.org/drawingml/2006/main" xmlns:p="http://schemas.openxmlformats.org/presentationml/2006/main" xmlns:r="http://schemas.openxmlformats.org/officeDocument/2006/relationships">
   <p:cSld>
     <p:spTree>
       <p:nvGrpSpPr>
@@ -5265,14 +5392,7 @@
         <p:cNvGrpSpPr/>
         <p:nvPr/>
       </p:nvGrpSpPr>
-      <p:grpSpPr>
-        <a:xfrm>
-          <a:off x="0" y="0"/>
-          <a:ext cx="0" cy="0"/>
-          <a:chOff x="0" y="0"/>
-          <a:chExt cx="0" cy="0"/>
-        </a:xfrm>
-      </p:grpSpPr>
+      <p:grpSpPr/>
       <p:sp>
         <p:nvSpPr>
           <p:cNvPr id="2" name="TextBox 1"/>
@@ -5294,9 +5414,7 @@
             <a:spAutoFit/>
           </a:bodyPr>
           <a:lstStyle/>
-          <a:p>
-            <a:endParaRPr/>
-          </a:p>
+          <a:p/>
           <a:p>
             <a:pPr>
               <a:defRPr sz="1000">
@@ -5332,12 +5450,10 @@
             <a:spAutoFit/>
           </a:bodyPr>
           <a:lstStyle/>
-          <a:p>
-            <a:endParaRPr/>
-          </a:p>
-          <a:p>
-            <a:pPr>
-              <a:defRPr sz="3600" b="1">
+          <a:p/>
+          <a:p>
+            <a:pPr>
+              <a:defRPr b="1" sz="3600">
                 <a:solidFill>
                   <a:srgbClr val="111827"/>
                 </a:solidFill>
@@ -5370,9 +5486,7 @@
             <a:spAutoFit/>
           </a:bodyPr>
           <a:lstStyle/>
-          <a:p>
-            <a:endParaRPr/>
-          </a:p>
+          <a:p/>
           <a:p>
             <a:pPr algn="ctr">
               <a:defRPr sz="1200" b="1">
@@ -5603,6 +5717,13 @@
           </a:p>
           <a:p>
             <a:br/>
+            <a:pPr algn="ctr">
+              <a:defRPr sz="1200" b="0">
+                <a:solidFill>
+                  <a:srgbClr val="64748B"/>
+                </a:solidFill>
+              </a:defRPr>
+            </a:pPr>
             <a:r>
               <a:t>*Note: Hardware (ESP32/Sensors) is planned / under development. Data transmission flows to ML processing and dashboard.</a:t>
             </a:r>
@@ -5618,7 +5739,7 @@
 </file>
 
 <file path=ppt/slides/slide13.xml><?xml version="1.0" encoding="utf-8"?>
-<p:sld xmlns:a="http://schemas.openxmlformats.org/drawingml/2006/main" xmlns:r="http://schemas.openxmlformats.org/officeDocument/2006/relationships" xmlns:p="http://schemas.openxmlformats.org/presentationml/2006/main">
+<p:sld xmlns:a="http://schemas.openxmlformats.org/drawingml/2006/main" xmlns:p="http://schemas.openxmlformats.org/presentationml/2006/main" xmlns:r="http://schemas.openxmlformats.org/officeDocument/2006/relationships">
   <p:cSld>
     <p:spTree>
       <p:nvGrpSpPr>
@@ -5626,14 +5747,7 @@
         <p:cNvGrpSpPr/>
         <p:nvPr/>
       </p:nvGrpSpPr>
-      <p:grpSpPr>
-        <a:xfrm>
-          <a:off x="0" y="0"/>
-          <a:ext cx="0" cy="0"/>
-          <a:chOff x="0" y="0"/>
-          <a:chExt cx="0" cy="0"/>
-        </a:xfrm>
-      </p:grpSpPr>
+      <p:grpSpPr/>
       <p:sp>
         <p:nvSpPr>
           <p:cNvPr id="2" name="TextBox 1"/>
@@ -5655,9 +5769,7 @@
             <a:spAutoFit/>
           </a:bodyPr>
           <a:lstStyle/>
-          <a:p>
-            <a:endParaRPr/>
-          </a:p>
+          <a:p/>
           <a:p>
             <a:pPr>
               <a:defRPr sz="1000">
@@ -5693,12 +5805,10 @@
             <a:spAutoFit/>
           </a:bodyPr>
           <a:lstStyle/>
-          <a:p>
-            <a:endParaRPr/>
-          </a:p>
-          <a:p>
-            <a:pPr>
-              <a:defRPr sz="3600" b="1">
+          <a:p/>
+          <a:p>
+            <a:pPr>
+              <a:defRPr b="1" sz="3600">
                 <a:solidFill>
                   <a:srgbClr val="111827"/>
                 </a:solidFill>
@@ -5729,34 +5839,10 @@
                 <a:tableStyleId>{5C22544A-7EE6-4342-B048-85BDC9FD1C3A}</a:tableStyleId>
               </a:tblPr>
               <a:tblGrid>
-                <a:gridCol w="2818638">
-                  <a:extLst>
-                    <a:ext uri="{9D8B030D-6E8A-4147-A177-3AD203B41FA5}">
-                      <a16:colId xmlns:a16="http://schemas.microsoft.com/office/drawing/2014/main" val="20000"/>
-                    </a:ext>
-                  </a:extLst>
-                </a:gridCol>
-                <a:gridCol w="2818638">
-                  <a:extLst>
-                    <a:ext uri="{9D8B030D-6E8A-4147-A177-3AD203B41FA5}">
-                      <a16:colId xmlns:a16="http://schemas.microsoft.com/office/drawing/2014/main" val="20001"/>
-                    </a:ext>
-                  </a:extLst>
-                </a:gridCol>
-                <a:gridCol w="2818638">
-                  <a:extLst>
-                    <a:ext uri="{9D8B030D-6E8A-4147-A177-3AD203B41FA5}">
-                      <a16:colId xmlns:a16="http://schemas.microsoft.com/office/drawing/2014/main" val="20002"/>
-                    </a:ext>
-                  </a:extLst>
-                </a:gridCol>
-                <a:gridCol w="2818638">
-                  <a:extLst>
-                    <a:ext uri="{9D8B030D-6E8A-4147-A177-3AD203B41FA5}">
-                      <a16:colId xmlns:a16="http://schemas.microsoft.com/office/drawing/2014/main" val="20003"/>
-                    </a:ext>
-                  </a:extLst>
-                </a:gridCol>
+                <a:gridCol w="2818638"/>
+                <a:gridCol w="2818638"/>
+                <a:gridCol w="2818638"/>
+                <a:gridCol w="2818638"/>
               </a:tblGrid>
               <a:tr h="400050">
                 <a:tc>
@@ -5765,7 +5851,7 @@
                     <a:lstStyle/>
                     <a:p>
                       <a:pPr>
-                        <a:defRPr sz="1400" b="1">
+                        <a:defRPr b="1" sz="1400">
                           <a:solidFill>
                             <a:srgbClr val="FFFFFF"/>
                           </a:solidFill>
@@ -5788,7 +5874,7 @@
                     <a:lstStyle/>
                     <a:p>
                       <a:pPr>
-                        <a:defRPr sz="1400" b="1">
+                        <a:defRPr b="1" sz="1400">
                           <a:solidFill>
                             <a:srgbClr val="FFFFFF"/>
                           </a:solidFill>
@@ -5811,7 +5897,7 @@
                     <a:lstStyle/>
                     <a:p>
                       <a:pPr>
-                        <a:defRPr sz="1400" b="1">
+                        <a:defRPr b="1" sz="1400">
                           <a:solidFill>
                             <a:srgbClr val="FFFFFF"/>
                           </a:solidFill>
@@ -5834,7 +5920,7 @@
                     <a:lstStyle/>
                     <a:p>
                       <a:pPr>
-                        <a:defRPr sz="1400" b="1">
+                        <a:defRPr b="1" sz="1400">
                           <a:solidFill>
                             <a:srgbClr val="FFFFFF"/>
                           </a:solidFill>
@@ -5851,11 +5937,6 @@
                     </a:solidFill>
                   </a:tcPr>
                 </a:tc>
-                <a:extLst>
-                  <a:ext uri="{0D108BD9-81ED-4DB2-BD59-A6C34878D82A}">
-                    <a16:rowId xmlns:a16="http://schemas.microsoft.com/office/drawing/2014/main" val="10000"/>
-                  </a:ext>
-                </a:extLst>
               </a:tr>
               <a:tr h="400050">
                 <a:tc>
@@ -5918,11 +5999,6 @@
                   </a:txBody>
                   <a:tcPr/>
                 </a:tc>
-                <a:extLst>
-                  <a:ext uri="{0D108BD9-81ED-4DB2-BD59-A6C34878D82A}">
-                    <a16:rowId xmlns:a16="http://schemas.microsoft.com/office/drawing/2014/main" val="10001"/>
-                  </a:ext>
-                </a:extLst>
               </a:tr>
               <a:tr h="400050">
                 <a:tc>
@@ -5985,11 +6061,6 @@
                   </a:txBody>
                   <a:tcPr/>
                 </a:tc>
-                <a:extLst>
-                  <a:ext uri="{0D108BD9-81ED-4DB2-BD59-A6C34878D82A}">
-                    <a16:rowId xmlns:a16="http://schemas.microsoft.com/office/drawing/2014/main" val="10002"/>
-                  </a:ext>
-                </a:extLst>
               </a:tr>
               <a:tr h="400050">
                 <a:tc>
@@ -6052,11 +6123,6 @@
                   </a:txBody>
                   <a:tcPr/>
                 </a:tc>
-                <a:extLst>
-                  <a:ext uri="{0D108BD9-81ED-4DB2-BD59-A6C34878D82A}">
-                    <a16:rowId xmlns:a16="http://schemas.microsoft.com/office/drawing/2014/main" val="10003"/>
-                  </a:ext>
-                </a:extLst>
               </a:tr>
               <a:tr h="400050">
                 <a:tc>
@@ -6119,11 +6185,6 @@
                   </a:txBody>
                   <a:tcPr/>
                 </a:tc>
-                <a:extLst>
-                  <a:ext uri="{0D108BD9-81ED-4DB2-BD59-A6C34878D82A}">
-                    <a16:rowId xmlns:a16="http://schemas.microsoft.com/office/drawing/2014/main" val="10004"/>
-                  </a:ext>
-                </a:extLst>
               </a:tr>
               <a:tr h="400050">
                 <a:tc>
@@ -6186,11 +6247,6 @@
                   </a:txBody>
                   <a:tcPr/>
                 </a:tc>
-                <a:extLst>
-                  <a:ext uri="{0D108BD9-81ED-4DB2-BD59-A6C34878D82A}">
-                    <a16:rowId xmlns:a16="http://schemas.microsoft.com/office/drawing/2014/main" val="10005"/>
-                  </a:ext>
-                </a:extLst>
               </a:tr>
               <a:tr h="400050">
                 <a:tc>
@@ -6253,11 +6309,6 @@
                   </a:txBody>
                   <a:tcPr/>
                 </a:tc>
-                <a:extLst>
-                  <a:ext uri="{0D108BD9-81ED-4DB2-BD59-A6C34878D82A}">
-                    <a16:rowId xmlns:a16="http://schemas.microsoft.com/office/drawing/2014/main" val="10006"/>
-                  </a:ext>
-                </a:extLst>
               </a:tr>
               <a:tr h="400050">
                 <a:tc>
@@ -6320,11 +6371,6 @@
                   </a:txBody>
                   <a:tcPr/>
                 </a:tc>
-                <a:extLst>
-                  <a:ext uri="{0D108BD9-81ED-4DB2-BD59-A6C34878D82A}">
-                    <a16:rowId xmlns:a16="http://schemas.microsoft.com/office/drawing/2014/main" val="10007"/>
-                  </a:ext>
-                </a:extLst>
               </a:tr>
             </a:tbl>
           </a:graphicData>
@@ -6351,9 +6397,7 @@
             <a:spAutoFit/>
           </a:bodyPr>
           <a:lstStyle/>
-          <a:p>
-            <a:endParaRPr/>
-          </a:p>
+          <a:p/>
           <a:p>
             <a:pPr algn="ctr">
               <a:defRPr sz="1600" b="1">
@@ -6381,7 +6425,7 @@
 </file>
 
 <file path=ppt/slides/slide14.xml><?xml version="1.0" encoding="utf-8"?>
-<p:sld xmlns:a="http://schemas.openxmlformats.org/drawingml/2006/main" xmlns:r="http://schemas.openxmlformats.org/officeDocument/2006/relationships" xmlns:p="http://schemas.openxmlformats.org/presentationml/2006/main">
+<p:sld xmlns:a="http://schemas.openxmlformats.org/drawingml/2006/main" xmlns:p="http://schemas.openxmlformats.org/presentationml/2006/main" xmlns:r="http://schemas.openxmlformats.org/officeDocument/2006/relationships">
   <p:cSld>
     <p:spTree>
       <p:nvGrpSpPr>
@@ -6389,14 +6433,7 @@
         <p:cNvGrpSpPr/>
         <p:nvPr/>
       </p:nvGrpSpPr>
-      <p:grpSpPr>
-        <a:xfrm>
-          <a:off x="0" y="0"/>
-          <a:ext cx="0" cy="0"/>
-          <a:chOff x="0" y="0"/>
-          <a:chExt cx="0" cy="0"/>
-        </a:xfrm>
-      </p:grpSpPr>
+      <p:grpSpPr/>
       <p:sp>
         <p:nvSpPr>
           <p:cNvPr id="2" name="TextBox 1"/>
@@ -6418,9 +6455,7 @@
             <a:spAutoFit/>
           </a:bodyPr>
           <a:lstStyle/>
-          <a:p>
-            <a:endParaRPr/>
-          </a:p>
+          <a:p/>
           <a:p>
             <a:pPr>
               <a:defRPr sz="1000">
@@ -6456,12 +6491,10 @@
             <a:spAutoFit/>
           </a:bodyPr>
           <a:lstStyle/>
-          <a:p>
-            <a:endParaRPr/>
-          </a:p>
-          <a:p>
-            <a:pPr>
-              <a:defRPr sz="3600" b="1">
+          <a:p/>
+          <a:p>
+            <a:pPr>
+              <a:defRPr b="1" sz="3600">
                 <a:solidFill>
                   <a:srgbClr val="111827"/>
                 </a:solidFill>
@@ -6494,19 +6527,16 @@
             <a:spAutoFit/>
           </a:bodyPr>
           <a:lstStyle/>
-          <a:p>
-            <a:endParaRPr dirty="0"/>
-          </a:p>
-          <a:p>
-            <a:pPr>
-              <a:defRPr sz="1800" b="1">
+          <a:p/>
+          <a:p>
+            <a:pPr>
+              <a:defRPr b="1" sz="1800">
                 <a:solidFill>
                   <a:srgbClr val="16A34A"/>
                 </a:solidFill>
               </a:defRPr>
             </a:pPr>
             <a:r>
-              <a:rPr dirty="0"/>
               <a:t>WORKING SOFTWARE PROTOTYPE</a:t>
             </a:r>
           </a:p>
@@ -6519,7 +6549,6 @@
               </a:defRPr>
             </a:pPr>
             <a:r>
-              <a:rPr dirty="0"/>
               <a:t>✓ Dashboard UI</a:t>
             </a:r>
           </a:p>
@@ -6532,7 +6561,6 @@
               </a:defRPr>
             </a:pPr>
             <a:r>
-              <a:rPr dirty="0"/>
               <a:t>✓ Sensor simulation</a:t>
             </a:r>
           </a:p>
@@ -6545,7 +6573,6 @@
               </a:defRPr>
             </a:pPr>
             <a:r>
-              <a:rPr dirty="0"/>
               <a:t>✓ Health visualization</a:t>
             </a:r>
           </a:p>
@@ -6558,7 +6585,6 @@
               </a:defRPr>
             </a:pPr>
             <a:r>
-              <a:rPr dirty="0"/>
               <a:t>✓ Condition indication</a:t>
             </a:r>
           </a:p>
@@ -6571,7 +6597,6 @@
               </a:defRPr>
             </a:pPr>
             <a:r>
-              <a:rPr dirty="0"/>
               <a:t>✓ Trend visualization</a:t>
             </a:r>
           </a:p>
@@ -6584,7 +6609,6 @@
               </a:defRPr>
             </a:pPr>
             <a:r>
-              <a:rPr dirty="0"/>
               <a:t>✓ System pipeline</a:t>
             </a:r>
           </a:p>
@@ -6597,111 +6621,135 @@
               </a:defRPr>
             </a:pPr>
             <a:r>
-              <a:rPr dirty="0"/>
               <a:t>✓ Dataset integration plan</a:t>
             </a:r>
           </a:p>
           <a:p>
-            <a:br>
-              <a:rPr dirty="0"/>
-            </a:br>
-            <a:r>
-              <a:rPr dirty="0"/>
+            <a:br/>
+            <a:pPr>
+              <a:defRPr b="1" sz="1400">
+                <a:solidFill>
+                  <a:srgbClr val="2563EB"/>
+                </a:solidFill>
+              </a:defRPr>
+            </a:pPr>
+            <a:r>
               <a:t>LIVE PROTOTYPE:</a:t>
             </a:r>
-            <a:br>
-              <a:rPr dirty="0"/>
-            </a:br>
-            <a:r>
-              <a:rPr dirty="0"/>
-              <a:t>https://bridgeguard-ai-alpha.vercel.app/</a:t>
-            </a:r>
-          </a:p>
-          <a:p>
-            <a:br>
-              <a:rPr dirty="0"/>
-            </a:br>
-            <a:r>
-              <a:rPr dirty="0"/>
+            <a:br/>
+            <a:r>
+              <a:t>https://bridgeguard-ml.vercel.app/</a:t>
+            </a:r>
+          </a:p>
+          <a:p>
+            <a:br/>
+            <a:pPr>
+              <a:defRPr b="1" sz="1400">
+                <a:solidFill>
+                  <a:srgbClr val="16A34A"/>
+                </a:solidFill>
+              </a:defRPr>
+            </a:pPr>
+            <a:r>
               <a:t>CURRENT STAGE:</a:t>
             </a:r>
-            <a:br>
-              <a:rPr dirty="0"/>
-            </a:br>
-            <a:r>
-              <a:rPr dirty="0"/>
+            <a:br/>
+            <a:r>
               <a:t>Software prototype + simulation</a:t>
             </a:r>
           </a:p>
           <a:p>
-            <a:br>
-              <a:rPr dirty="0"/>
-            </a:br>
-            <a:r>
-              <a:rPr dirty="0"/>
+            <a:br/>
+            <a:pPr>
+              <a:defRPr b="1" sz="1400">
+                <a:solidFill>
+                  <a:srgbClr val="F59E0B"/>
+                </a:solidFill>
+              </a:defRPr>
+            </a:pPr>
+            <a:r>
               <a:t>IN PROGRESS:</a:t>
             </a:r>
-            <a:br>
-              <a:rPr dirty="0"/>
-            </a:br>
-            <a:r>
-              <a:rPr dirty="0"/>
+            <a:br/>
+            <a:r>
               <a:t>→ Real dataset preprocessing</a:t>
             </a:r>
-            <a:br>
-              <a:rPr dirty="0"/>
-            </a:br>
-            <a:r>
-              <a:rPr dirty="0"/>
+            <a:br/>
+            <a:r>
               <a:t>→ Health-relative feature extraction</a:t>
             </a:r>
-            <a:br>
-              <a:rPr dirty="0"/>
-            </a:br>
-            <a:r>
-              <a:rPr dirty="0"/>
+            <a:br/>
+            <a:r>
               <a:t>→ ML comparison &amp; SHAP integration</a:t>
             </a:r>
-            <a:br>
-              <a:rPr dirty="0"/>
-            </a:br>
-            <a:r>
-              <a:rPr dirty="0"/>
+            <a:br/>
+            <a:r>
               <a:t>→ Hardware integration</a:t>
             </a:r>
           </a:p>
         </p:txBody>
       </p:sp>
-      <p:pic>
-        <p:nvPicPr>
-          <p:cNvPr id="9" name="Picture 8">
-            <a:extLst>
-              <a:ext uri="{FF2B5EF4-FFF2-40B4-BE49-F238E27FC236}">
-                <a16:creationId xmlns:a16="http://schemas.microsoft.com/office/drawing/2014/main" id="{5EDFECE5-173C-6064-FA2E-12ABFA5F733D}"/>
-              </a:ext>
-            </a:extLst>
-          </p:cNvPr>
-          <p:cNvPicPr>
-            <a:picLocks noChangeAspect="1"/>
-          </p:cNvPicPr>
+      <p:sp>
+        <p:nvSpPr>
+          <p:cNvPr id="5" name="Rectangle 4"/>
+          <p:cNvSpPr/>
           <p:nvPr/>
-        </p:nvPicPr>
-        <p:blipFill>
-          <a:blip r:embed="rId3"/>
-          <a:stretch>
-            <a:fillRect/>
-          </a:stretch>
-        </p:blipFill>
+        </p:nvSpPr>
         <p:spPr>
           <a:xfrm>
-            <a:off x="5132489" y="1397448"/>
-            <a:ext cx="5900523" cy="4886064"/>
+            <a:off x="5943600" y="1371600"/>
+            <a:ext cx="5486400" cy="4114800"/>
           </a:xfrm>
           <a:prstGeom prst="rect">
             <a:avLst/>
           </a:prstGeom>
+          <a:solidFill>
+            <a:srgbClr val="F1F5F9"/>
+          </a:solidFill>
+          <a:ln>
+            <a:solidFill>
+              <a:srgbClr val="CBD5E1"/>
+            </a:solidFill>
+          </a:ln>
         </p:spPr>
-      </p:pic>
+        <p:style>
+          <a:lnRef idx="1">
+            <a:schemeClr val="accent1"/>
+          </a:lnRef>
+          <a:fillRef idx="3">
+            <a:schemeClr val="accent1"/>
+          </a:fillRef>
+          <a:effectRef idx="2">
+            <a:schemeClr val="accent1"/>
+          </a:effectRef>
+          <a:fontRef idx="minor">
+            <a:schemeClr val="lt1"/>
+          </a:fontRef>
+        </p:style>
+        <p:txBody>
+          <a:bodyPr rtlCol="0" anchor="ctr"/>
+          <a:lstStyle/>
+          <a:p>
+            <a:pPr algn="ctr"/>
+          </a:p>
+          <a:p>
+            <a:pPr algn="ctr">
+              <a:defRPr sz="1600" b="1">
+                <a:solidFill>
+                  <a:srgbClr val="64748B"/>
+                </a:solidFill>
+              </a:defRPr>
+            </a:pPr>
+            <a:r>
+              <a:t>[ BRIDGEGUARD ML WEB DASHBOARD ]</a:t>
+            </a:r>
+            <a:br/>
+            <a:r>
+              <a:t>(Insert Dashboard Screenshot Here)</a:t>
+            </a:r>
+          </a:p>
+        </p:txBody>
+      </p:sp>
     </p:spTree>
   </p:cSld>
   <p:clrMapOvr>
@@ -6711,7 +6759,7 @@
 </file>
 
 <file path=ppt/slides/slide15.xml><?xml version="1.0" encoding="utf-8"?>
-<p:sld xmlns:a="http://schemas.openxmlformats.org/drawingml/2006/main" xmlns:r="http://schemas.openxmlformats.org/officeDocument/2006/relationships" xmlns:p="http://schemas.openxmlformats.org/presentationml/2006/main">
+<p:sld xmlns:a="http://schemas.openxmlformats.org/drawingml/2006/main" xmlns:p="http://schemas.openxmlformats.org/presentationml/2006/main" xmlns:r="http://schemas.openxmlformats.org/officeDocument/2006/relationships">
   <p:cSld>
     <p:spTree>
       <p:nvGrpSpPr>
@@ -6719,14 +6767,7 @@
         <p:cNvGrpSpPr/>
         <p:nvPr/>
       </p:nvGrpSpPr>
-      <p:grpSpPr>
-        <a:xfrm>
-          <a:off x="0" y="0"/>
-          <a:ext cx="0" cy="0"/>
-          <a:chOff x="0" y="0"/>
-          <a:chExt cx="0" cy="0"/>
-        </a:xfrm>
-      </p:grpSpPr>
+      <p:grpSpPr/>
       <p:sp>
         <p:nvSpPr>
           <p:cNvPr id="2" name="TextBox 1"/>
@@ -6748,9 +6789,7 @@
             <a:spAutoFit/>
           </a:bodyPr>
           <a:lstStyle/>
-          <a:p>
-            <a:endParaRPr/>
-          </a:p>
+          <a:p/>
           <a:p>
             <a:pPr>
               <a:defRPr sz="1000">
@@ -6786,12 +6825,10 @@
             <a:spAutoFit/>
           </a:bodyPr>
           <a:lstStyle/>
-          <a:p>
-            <a:endParaRPr/>
-          </a:p>
-          <a:p>
-            <a:pPr>
-              <a:defRPr sz="3600" b="1">
+          <a:p/>
+          <a:p>
+            <a:pPr>
+              <a:defRPr b="1" sz="3600">
                 <a:solidFill>
                   <a:srgbClr val="111827"/>
                 </a:solidFill>
@@ -6824,12 +6861,10 @@
             <a:spAutoFit/>
           </a:bodyPr>
           <a:lstStyle/>
-          <a:p>
-            <a:endParaRPr/>
-          </a:p>
-          <a:p>
-            <a:pPr>
-              <a:defRPr sz="1800" b="1">
+          <a:p/>
+          <a:p>
+            <a:pPr>
+              <a:defRPr b="1" sz="1800">
                 <a:solidFill>
                   <a:srgbClr val="2563EB"/>
                 </a:solidFill>
@@ -6952,12 +6987,10 @@
             <a:spAutoFit/>
           </a:bodyPr>
           <a:lstStyle/>
-          <a:p>
-            <a:endParaRPr/>
-          </a:p>
-          <a:p>
-            <a:pPr>
-              <a:defRPr sz="1800" b="1">
+          <a:p/>
+          <a:p>
+            <a:pPr>
+              <a:defRPr b="1" sz="1800">
                 <a:solidFill>
                   <a:srgbClr val="F59E0B"/>
                 </a:solidFill>
@@ -7128,7 +7161,7 @@
 </file>
 
 <file path=ppt/slides/slide16.xml><?xml version="1.0" encoding="utf-8"?>
-<p:sld xmlns:a="http://schemas.openxmlformats.org/drawingml/2006/main" xmlns:r="http://schemas.openxmlformats.org/officeDocument/2006/relationships" xmlns:p="http://schemas.openxmlformats.org/presentationml/2006/main">
+<p:sld xmlns:a="http://schemas.openxmlformats.org/drawingml/2006/main" xmlns:p="http://schemas.openxmlformats.org/presentationml/2006/main" xmlns:r="http://schemas.openxmlformats.org/officeDocument/2006/relationships">
   <p:cSld>
     <p:spTree>
       <p:nvGrpSpPr>
@@ -7136,14 +7169,7 @@
         <p:cNvGrpSpPr/>
         <p:nvPr/>
       </p:nvGrpSpPr>
-      <p:grpSpPr>
-        <a:xfrm>
-          <a:off x="0" y="0"/>
-          <a:ext cx="0" cy="0"/>
-          <a:chOff x="0" y="0"/>
-          <a:chExt cx="0" cy="0"/>
-        </a:xfrm>
-      </p:grpSpPr>
+      <p:grpSpPr/>
       <p:sp>
         <p:nvSpPr>
           <p:cNvPr id="2" name="TextBox 1"/>
@@ -7165,9 +7191,7 @@
             <a:spAutoFit/>
           </a:bodyPr>
           <a:lstStyle/>
-          <a:p>
-            <a:endParaRPr/>
-          </a:p>
+          <a:p/>
           <a:p>
             <a:pPr>
               <a:defRPr sz="1000">
@@ -7203,12 +7227,10 @@
             <a:spAutoFit/>
           </a:bodyPr>
           <a:lstStyle/>
-          <a:p>
-            <a:endParaRPr/>
-          </a:p>
-          <a:p>
-            <a:pPr>
-              <a:defRPr sz="3600" b="1">
+          <a:p/>
+          <a:p>
+            <a:pPr>
+              <a:defRPr b="1" sz="3600">
                 <a:solidFill>
                   <a:srgbClr val="111827"/>
                 </a:solidFill>
@@ -7241,9 +7263,7 @@
             <a:spAutoFit/>
           </a:bodyPr>
           <a:lstStyle/>
-          <a:p>
-            <a:endParaRPr/>
-          </a:p>
+          <a:p/>
           <a:p>
             <a:pPr>
               <a:spcAft>
@@ -7495,7 +7515,7 @@
 </file>
 
 <file path=ppt/slides/slide2.xml><?xml version="1.0" encoding="utf-8"?>
-<p:sld xmlns:a="http://schemas.openxmlformats.org/drawingml/2006/main" xmlns:r="http://schemas.openxmlformats.org/officeDocument/2006/relationships" xmlns:p="http://schemas.openxmlformats.org/presentationml/2006/main">
+<p:sld xmlns:a="http://schemas.openxmlformats.org/drawingml/2006/main" xmlns:p="http://schemas.openxmlformats.org/presentationml/2006/main" xmlns:r="http://schemas.openxmlformats.org/officeDocument/2006/relationships">
   <p:cSld>
     <p:spTree>
       <p:nvGrpSpPr>
@@ -7503,14 +7523,7 @@
         <p:cNvGrpSpPr/>
         <p:nvPr/>
       </p:nvGrpSpPr>
-      <p:grpSpPr>
-        <a:xfrm>
-          <a:off x="0" y="0"/>
-          <a:ext cx="0" cy="0"/>
-          <a:chOff x="0" y="0"/>
-          <a:chExt cx="0" cy="0"/>
-        </a:xfrm>
-      </p:grpSpPr>
+      <p:grpSpPr/>
       <p:sp>
         <p:nvSpPr>
           <p:cNvPr id="2" name="TextBox 1"/>
@@ -7532,9 +7545,7 @@
             <a:spAutoFit/>
           </a:bodyPr>
           <a:lstStyle/>
-          <a:p>
-            <a:endParaRPr/>
-          </a:p>
+          <a:p/>
           <a:p>
             <a:pPr>
               <a:defRPr sz="1000">
@@ -7570,12 +7581,10 @@
             <a:spAutoFit/>
           </a:bodyPr>
           <a:lstStyle/>
-          <a:p>
-            <a:endParaRPr/>
-          </a:p>
-          <a:p>
-            <a:pPr>
-              <a:defRPr sz="3600" b="1">
+          <a:p/>
+          <a:p>
+            <a:pPr>
+              <a:defRPr b="1" sz="3600">
                 <a:solidFill>
                   <a:srgbClr val="111827"/>
                 </a:solidFill>
@@ -7608,9 +7617,7 @@
             <a:spAutoFit/>
           </a:bodyPr>
           <a:lstStyle/>
-          <a:p>
-            <a:endParaRPr/>
-          </a:p>
+          <a:p/>
           <a:p>
             <a:pPr>
               <a:spcAft>
@@ -7709,9 +7716,7 @@
             <a:spAutoFit/>
           </a:bodyPr>
           <a:lstStyle/>
-          <a:p>
-            <a:endParaRPr/>
-          </a:p>
+          <a:p/>
           <a:p>
             <a:pPr>
               <a:spcAft>
@@ -7798,7 +7803,7 @@
 </file>
 
 <file path=ppt/slides/slide3.xml><?xml version="1.0" encoding="utf-8"?>
-<p:sld xmlns:a="http://schemas.openxmlformats.org/drawingml/2006/main" xmlns:r="http://schemas.openxmlformats.org/officeDocument/2006/relationships" xmlns:p="http://schemas.openxmlformats.org/presentationml/2006/main">
+<p:sld xmlns:a="http://schemas.openxmlformats.org/drawingml/2006/main" xmlns:p="http://schemas.openxmlformats.org/presentationml/2006/main" xmlns:r="http://schemas.openxmlformats.org/officeDocument/2006/relationships">
   <p:cSld>
     <p:spTree>
       <p:nvGrpSpPr>
@@ -7806,14 +7811,7 @@
         <p:cNvGrpSpPr/>
         <p:nvPr/>
       </p:nvGrpSpPr>
-      <p:grpSpPr>
-        <a:xfrm>
-          <a:off x="0" y="0"/>
-          <a:ext cx="0" cy="0"/>
-          <a:chOff x="0" y="0"/>
-          <a:chExt cx="0" cy="0"/>
-        </a:xfrm>
-      </p:grpSpPr>
+      <p:grpSpPr/>
       <p:sp>
         <p:nvSpPr>
           <p:cNvPr id="2" name="TextBox 1"/>
@@ -7835,9 +7833,7 @@
             <a:spAutoFit/>
           </a:bodyPr>
           <a:lstStyle/>
-          <a:p>
-            <a:endParaRPr/>
-          </a:p>
+          <a:p/>
           <a:p>
             <a:pPr>
               <a:defRPr sz="1000">
@@ -7873,12 +7869,10 @@
             <a:spAutoFit/>
           </a:bodyPr>
           <a:lstStyle/>
-          <a:p>
-            <a:endParaRPr/>
-          </a:p>
-          <a:p>
-            <a:pPr>
-              <a:defRPr sz="3600" b="1">
+          <a:p/>
+          <a:p>
+            <a:pPr>
+              <a:defRPr b="1" sz="3600">
                 <a:solidFill>
                   <a:srgbClr val="111827"/>
                 </a:solidFill>
@@ -7911,9 +7905,7 @@
             <a:spAutoFit/>
           </a:bodyPr>
           <a:lstStyle/>
-          <a:p>
-            <a:endParaRPr/>
-          </a:p>
+          <a:p/>
           <a:p>
             <a:pPr>
               <a:spcAft>
@@ -8030,7 +8022,7 @@
         <p:spPr>
           <a:xfrm>
             <a:off x="457200" y="5029200"/>
-            <a:ext cx="9716763" cy="1231106"/>
+            <a:ext cx="11274552" cy="1371600"/>
           </a:xfrm>
           <a:prstGeom prst="rect">
             <a:avLst/>
@@ -8049,19 +8041,16 @@
             <a:spAutoFit/>
           </a:bodyPr>
           <a:lstStyle/>
-          <a:p>
-            <a:endParaRPr dirty="0"/>
-          </a:p>
-          <a:p>
-            <a:pPr>
-              <a:defRPr sz="1600" b="1">
+          <a:p/>
+          <a:p>
+            <a:pPr>
+              <a:defRPr b="1" sz="1600">
                 <a:solidFill>
                   <a:srgbClr val="2563EB"/>
                 </a:solidFill>
               </a:defRPr>
             </a:pPr>
             <a:r>
-              <a:rPr dirty="0"/>
               <a:t>RESEARCH CHALLENGE</a:t>
             </a:r>
           </a:p>
@@ -8074,15 +8063,7 @@
               </a:defRPr>
             </a:pPr>
             <a:r>
-              <a:rPr dirty="0"/>
-              <a:t>How can ML-based bridge condition detection remain relevant to bridge-specific behavior</a:t>
-            </a:r>
-            <a:br>
-              <a:rPr lang="en-IN" dirty="0"/>
-            </a:br>
-            <a:r>
-              <a:rPr dirty="0"/>
-              <a:t> while providing interpretable predictions?</a:t>
+              <a:t>How can ML-based bridge condition detection remain relevant to bridge-specific behavior while providing interpretable predictions?</a:t>
             </a:r>
           </a:p>
         </p:txBody>
@@ -8096,7 +8077,7 @@
 </file>
 
 <file path=ppt/slides/slide4.xml><?xml version="1.0" encoding="utf-8"?>
-<p:sld xmlns:a="http://schemas.openxmlformats.org/drawingml/2006/main" xmlns:r="http://schemas.openxmlformats.org/officeDocument/2006/relationships" xmlns:p="http://schemas.openxmlformats.org/presentationml/2006/main">
+<p:sld xmlns:a="http://schemas.openxmlformats.org/drawingml/2006/main" xmlns:p="http://schemas.openxmlformats.org/presentationml/2006/main" xmlns:r="http://schemas.openxmlformats.org/officeDocument/2006/relationships">
   <p:cSld>
     <p:spTree>
       <p:nvGrpSpPr>
@@ -8104,14 +8085,7 @@
         <p:cNvGrpSpPr/>
         <p:nvPr/>
       </p:nvGrpSpPr>
-      <p:grpSpPr>
-        <a:xfrm>
-          <a:off x="0" y="0"/>
-          <a:ext cx="0" cy="0"/>
-          <a:chOff x="0" y="0"/>
-          <a:chExt cx="0" cy="0"/>
-        </a:xfrm>
-      </p:grpSpPr>
+      <p:grpSpPr/>
       <p:sp>
         <p:nvSpPr>
           <p:cNvPr id="2" name="TextBox 1"/>
@@ -8133,9 +8107,7 @@
             <a:spAutoFit/>
           </a:bodyPr>
           <a:lstStyle/>
-          <a:p>
-            <a:endParaRPr/>
-          </a:p>
+          <a:p/>
           <a:p>
             <a:pPr>
               <a:defRPr sz="1000">
@@ -8171,12 +8143,10 @@
             <a:spAutoFit/>
           </a:bodyPr>
           <a:lstStyle/>
-          <a:p>
-            <a:endParaRPr/>
-          </a:p>
-          <a:p>
-            <a:pPr>
-              <a:defRPr sz="3600" b="1">
+          <a:p/>
+          <a:p>
+            <a:pPr>
+              <a:defRPr b="1" sz="3600">
                 <a:solidFill>
                   <a:srgbClr val="111827"/>
                 </a:solidFill>
@@ -8207,41 +8177,11 @@
                 <a:tableStyleId>{5C22544A-7EE6-4342-B048-85BDC9FD1C3A}</a:tableStyleId>
               </a:tblPr>
               <a:tblGrid>
-                <a:gridCol w="2254910">
-                  <a:extLst>
-                    <a:ext uri="{9D8B030D-6E8A-4147-A177-3AD203B41FA5}">
-                      <a16:colId xmlns:a16="http://schemas.microsoft.com/office/drawing/2014/main" val="20000"/>
-                    </a:ext>
-                  </a:extLst>
-                </a:gridCol>
-                <a:gridCol w="2254910">
-                  <a:extLst>
-                    <a:ext uri="{9D8B030D-6E8A-4147-A177-3AD203B41FA5}">
-                      <a16:colId xmlns:a16="http://schemas.microsoft.com/office/drawing/2014/main" val="20001"/>
-                    </a:ext>
-                  </a:extLst>
-                </a:gridCol>
-                <a:gridCol w="2254910">
-                  <a:extLst>
-                    <a:ext uri="{9D8B030D-6E8A-4147-A177-3AD203B41FA5}">
-                      <a16:colId xmlns:a16="http://schemas.microsoft.com/office/drawing/2014/main" val="20002"/>
-                    </a:ext>
-                  </a:extLst>
-                </a:gridCol>
-                <a:gridCol w="2254910">
-                  <a:extLst>
-                    <a:ext uri="{9D8B030D-6E8A-4147-A177-3AD203B41FA5}">
-                      <a16:colId xmlns:a16="http://schemas.microsoft.com/office/drawing/2014/main" val="20003"/>
-                    </a:ext>
-                  </a:extLst>
-                </a:gridCol>
-                <a:gridCol w="2254912">
-                  <a:extLst>
-                    <a:ext uri="{9D8B030D-6E8A-4147-A177-3AD203B41FA5}">
-                      <a16:colId xmlns:a16="http://schemas.microsoft.com/office/drawing/2014/main" val="20004"/>
-                    </a:ext>
-                  </a:extLst>
-                </a:gridCol>
+                <a:gridCol w="2254910"/>
+                <a:gridCol w="2254910"/>
+                <a:gridCol w="2254910"/>
+                <a:gridCol w="2254910"/>
+                <a:gridCol w="2254912"/>
               </a:tblGrid>
               <a:tr h="1143000">
                 <a:tc>
@@ -8250,7 +8190,7 @@
                     <a:lstStyle/>
                     <a:p>
                       <a:pPr>
-                        <a:defRPr sz="1400" b="1">
+                        <a:defRPr b="1" sz="1400">
                           <a:solidFill>
                             <a:srgbClr val="FFFFFF"/>
                           </a:solidFill>
@@ -8273,7 +8213,7 @@
                     <a:lstStyle/>
                     <a:p>
                       <a:pPr>
-                        <a:defRPr sz="1400" b="1">
+                        <a:defRPr b="1" sz="1400">
                           <a:solidFill>
                             <a:srgbClr val="FFFFFF"/>
                           </a:solidFill>
@@ -8296,7 +8236,7 @@
                     <a:lstStyle/>
                     <a:p>
                       <a:pPr>
-                        <a:defRPr sz="1400" b="1">
+                        <a:defRPr b="1" sz="1400">
                           <a:solidFill>
                             <a:srgbClr val="FFFFFF"/>
                           </a:solidFill>
@@ -8319,7 +8259,7 @@
                     <a:lstStyle/>
                     <a:p>
                       <a:pPr>
-                        <a:defRPr sz="1400" b="1">
+                        <a:defRPr b="1" sz="1400">
                           <a:solidFill>
                             <a:srgbClr val="FFFFFF"/>
                           </a:solidFill>
@@ -8342,7 +8282,7 @@
                     <a:lstStyle/>
                     <a:p>
                       <a:pPr>
-                        <a:defRPr sz="1400" b="1">
+                        <a:defRPr b="1" sz="1400">
                           <a:solidFill>
                             <a:srgbClr val="FFFFFF"/>
                           </a:solidFill>
@@ -8359,11 +8299,6 @@
                     </a:solidFill>
                   </a:tcPr>
                 </a:tc>
-                <a:extLst>
-                  <a:ext uri="{0D108BD9-81ED-4DB2-BD59-A6C34878D82A}">
-                    <a16:rowId xmlns:a16="http://schemas.microsoft.com/office/drawing/2014/main" val="10000"/>
-                  </a:ext>
-                </a:extLst>
               </a:tr>
               <a:tr h="1143000">
                 <a:tc>
@@ -8461,11 +8396,6 @@
                   </a:txBody>
                   <a:tcPr/>
                 </a:tc>
-                <a:extLst>
-                  <a:ext uri="{0D108BD9-81ED-4DB2-BD59-A6C34878D82A}">
-                    <a16:rowId xmlns:a16="http://schemas.microsoft.com/office/drawing/2014/main" val="10001"/>
-                  </a:ext>
-                </a:extLst>
               </a:tr>
               <a:tr h="1143000">
                 <a:tc>
@@ -8563,11 +8493,6 @@
                   </a:txBody>
                   <a:tcPr/>
                 </a:tc>
-                <a:extLst>
-                  <a:ext uri="{0D108BD9-81ED-4DB2-BD59-A6C34878D82A}">
-                    <a16:rowId xmlns:a16="http://schemas.microsoft.com/office/drawing/2014/main" val="10002"/>
-                  </a:ext>
-                </a:extLst>
               </a:tr>
               <a:tr h="1143000">
                 <a:tc>
@@ -8665,11 +8590,6 @@
                   </a:txBody>
                   <a:tcPr/>
                 </a:tc>
-                <a:extLst>
-                  <a:ext uri="{0D108BD9-81ED-4DB2-BD59-A6C34878D82A}">
-                    <a16:rowId xmlns:a16="http://schemas.microsoft.com/office/drawing/2014/main" val="10003"/>
-                  </a:ext>
-                </a:extLst>
               </a:tr>
             </a:tbl>
           </a:graphicData>
@@ -8684,7 +8604,7 @@
 </file>
 
 <file path=ppt/slides/slide5.xml><?xml version="1.0" encoding="utf-8"?>
-<p:sld xmlns:a="http://schemas.openxmlformats.org/drawingml/2006/main" xmlns:r="http://schemas.openxmlformats.org/officeDocument/2006/relationships" xmlns:p="http://schemas.openxmlformats.org/presentationml/2006/main">
+<p:sld xmlns:a="http://schemas.openxmlformats.org/drawingml/2006/main" xmlns:p="http://schemas.openxmlformats.org/presentationml/2006/main" xmlns:r="http://schemas.openxmlformats.org/officeDocument/2006/relationships">
   <p:cSld>
     <p:spTree>
       <p:nvGrpSpPr>
@@ -8692,14 +8612,7 @@
         <p:cNvGrpSpPr/>
         <p:nvPr/>
       </p:nvGrpSpPr>
-      <p:grpSpPr>
-        <a:xfrm>
-          <a:off x="0" y="0"/>
-          <a:ext cx="0" cy="0"/>
-          <a:chOff x="0" y="0"/>
-          <a:chExt cx="0" cy="0"/>
-        </a:xfrm>
-      </p:grpSpPr>
+      <p:grpSpPr/>
       <p:sp>
         <p:nvSpPr>
           <p:cNvPr id="2" name="TextBox 1"/>
@@ -8721,9 +8634,7 @@
             <a:spAutoFit/>
           </a:bodyPr>
           <a:lstStyle/>
-          <a:p>
-            <a:endParaRPr/>
-          </a:p>
+          <a:p/>
           <a:p>
             <a:pPr>
               <a:defRPr sz="1000">
@@ -8759,12 +8670,10 @@
             <a:spAutoFit/>
           </a:bodyPr>
           <a:lstStyle/>
-          <a:p>
-            <a:endParaRPr/>
-          </a:p>
-          <a:p>
-            <a:pPr>
-              <a:defRPr sz="3600" b="1">
+          <a:p/>
+          <a:p>
+            <a:pPr>
+              <a:defRPr b="1" sz="3600">
                 <a:solidFill>
                   <a:srgbClr val="111827"/>
                 </a:solidFill>
@@ -8795,41 +8704,11 @@
                 <a:tableStyleId>{5C22544A-7EE6-4342-B048-85BDC9FD1C3A}</a:tableStyleId>
               </a:tblPr>
               <a:tblGrid>
-                <a:gridCol w="2254910">
-                  <a:extLst>
-                    <a:ext uri="{9D8B030D-6E8A-4147-A177-3AD203B41FA5}">
-                      <a16:colId xmlns:a16="http://schemas.microsoft.com/office/drawing/2014/main" val="20000"/>
-                    </a:ext>
-                  </a:extLst>
-                </a:gridCol>
-                <a:gridCol w="2254910">
-                  <a:extLst>
-                    <a:ext uri="{9D8B030D-6E8A-4147-A177-3AD203B41FA5}">
-                      <a16:colId xmlns:a16="http://schemas.microsoft.com/office/drawing/2014/main" val="20001"/>
-                    </a:ext>
-                  </a:extLst>
-                </a:gridCol>
-                <a:gridCol w="2254910">
-                  <a:extLst>
-                    <a:ext uri="{9D8B030D-6E8A-4147-A177-3AD203B41FA5}">
-                      <a16:colId xmlns:a16="http://schemas.microsoft.com/office/drawing/2014/main" val="20002"/>
-                    </a:ext>
-                  </a:extLst>
-                </a:gridCol>
-                <a:gridCol w="2254910">
-                  <a:extLst>
-                    <a:ext uri="{9D8B030D-6E8A-4147-A177-3AD203B41FA5}">
-                      <a16:colId xmlns:a16="http://schemas.microsoft.com/office/drawing/2014/main" val="20003"/>
-                    </a:ext>
-                  </a:extLst>
-                </a:gridCol>
-                <a:gridCol w="2254912">
-                  <a:extLst>
-                    <a:ext uri="{9D8B030D-6E8A-4147-A177-3AD203B41FA5}">
-                      <a16:colId xmlns:a16="http://schemas.microsoft.com/office/drawing/2014/main" val="20004"/>
-                    </a:ext>
-                  </a:extLst>
-                </a:gridCol>
+                <a:gridCol w="2254910"/>
+                <a:gridCol w="2254910"/>
+                <a:gridCol w="2254910"/>
+                <a:gridCol w="2254910"/>
+                <a:gridCol w="2254912"/>
               </a:tblGrid>
               <a:tr h="1143000">
                 <a:tc>
@@ -8838,7 +8717,7 @@
                     <a:lstStyle/>
                     <a:p>
                       <a:pPr>
-                        <a:defRPr sz="1400" b="1">
+                        <a:defRPr b="1" sz="1400">
                           <a:solidFill>
                             <a:srgbClr val="FFFFFF"/>
                           </a:solidFill>
@@ -8861,7 +8740,7 @@
                     <a:lstStyle/>
                     <a:p>
                       <a:pPr>
-                        <a:defRPr sz="1400" b="1">
+                        <a:defRPr b="1" sz="1400">
                           <a:solidFill>
                             <a:srgbClr val="FFFFFF"/>
                           </a:solidFill>
@@ -8884,7 +8763,7 @@
                     <a:lstStyle/>
                     <a:p>
                       <a:pPr>
-                        <a:defRPr sz="1400" b="1">
+                        <a:defRPr b="1" sz="1400">
                           <a:solidFill>
                             <a:srgbClr val="FFFFFF"/>
                           </a:solidFill>
@@ -8907,7 +8786,7 @@
                     <a:lstStyle/>
                     <a:p>
                       <a:pPr>
-                        <a:defRPr sz="1400" b="1">
+                        <a:defRPr b="1" sz="1400">
                           <a:solidFill>
                             <a:srgbClr val="FFFFFF"/>
                           </a:solidFill>
@@ -8930,7 +8809,7 @@
                     <a:lstStyle/>
                     <a:p>
                       <a:pPr>
-                        <a:defRPr sz="1400" b="1">
+                        <a:defRPr b="1" sz="1400">
                           <a:solidFill>
                             <a:srgbClr val="FFFFFF"/>
                           </a:solidFill>
@@ -8947,11 +8826,6 @@
                     </a:solidFill>
                   </a:tcPr>
                 </a:tc>
-                <a:extLst>
-                  <a:ext uri="{0D108BD9-81ED-4DB2-BD59-A6C34878D82A}">
-                    <a16:rowId xmlns:a16="http://schemas.microsoft.com/office/drawing/2014/main" val="10000"/>
-                  </a:ext>
-                </a:extLst>
               </a:tr>
               <a:tr h="1143000">
                 <a:tc>
@@ -9049,11 +8923,6 @@
                   </a:txBody>
                   <a:tcPr/>
                 </a:tc>
-                <a:extLst>
-                  <a:ext uri="{0D108BD9-81ED-4DB2-BD59-A6C34878D82A}">
-                    <a16:rowId xmlns:a16="http://schemas.microsoft.com/office/drawing/2014/main" val="10001"/>
-                  </a:ext>
-                </a:extLst>
               </a:tr>
               <a:tr h="1143000">
                 <a:tc>
@@ -9151,11 +9020,6 @@
                   </a:txBody>
                   <a:tcPr/>
                 </a:tc>
-                <a:extLst>
-                  <a:ext uri="{0D108BD9-81ED-4DB2-BD59-A6C34878D82A}">
-                    <a16:rowId xmlns:a16="http://schemas.microsoft.com/office/drawing/2014/main" val="10002"/>
-                  </a:ext>
-                </a:extLst>
               </a:tr>
               <a:tr h="1143000">
                 <a:tc>
@@ -9253,11 +9117,6 @@
                   </a:txBody>
                   <a:tcPr/>
                 </a:tc>
-                <a:extLst>
-                  <a:ext uri="{0D108BD9-81ED-4DB2-BD59-A6C34878D82A}">
-                    <a16:rowId xmlns:a16="http://schemas.microsoft.com/office/drawing/2014/main" val="10003"/>
-                  </a:ext>
-                </a:extLst>
               </a:tr>
             </a:tbl>
           </a:graphicData>
@@ -9272,7 +9131,7 @@
 </file>
 
 <file path=ppt/slides/slide6.xml><?xml version="1.0" encoding="utf-8"?>
-<p:sld xmlns:a="http://schemas.openxmlformats.org/drawingml/2006/main" xmlns:r="http://schemas.openxmlformats.org/officeDocument/2006/relationships" xmlns:p="http://schemas.openxmlformats.org/presentationml/2006/main">
+<p:sld xmlns:a="http://schemas.openxmlformats.org/drawingml/2006/main" xmlns:p="http://schemas.openxmlformats.org/presentationml/2006/main" xmlns:r="http://schemas.openxmlformats.org/officeDocument/2006/relationships">
   <p:cSld>
     <p:spTree>
       <p:nvGrpSpPr>
@@ -9280,14 +9139,7 @@
         <p:cNvGrpSpPr/>
         <p:nvPr/>
       </p:nvGrpSpPr>
-      <p:grpSpPr>
-        <a:xfrm>
-          <a:off x="0" y="0"/>
-          <a:ext cx="0" cy="0"/>
-          <a:chOff x="0" y="0"/>
-          <a:chExt cx="0" cy="0"/>
-        </a:xfrm>
-      </p:grpSpPr>
+      <p:grpSpPr/>
       <p:sp>
         <p:nvSpPr>
           <p:cNvPr id="2" name="TextBox 1"/>
@@ -9309,9 +9161,7 @@
             <a:spAutoFit/>
           </a:bodyPr>
           <a:lstStyle/>
-          <a:p>
-            <a:endParaRPr/>
-          </a:p>
+          <a:p/>
           <a:p>
             <a:pPr>
               <a:defRPr sz="1000">
@@ -9347,12 +9197,10 @@
             <a:spAutoFit/>
           </a:bodyPr>
           <a:lstStyle/>
-          <a:p>
-            <a:endParaRPr/>
-          </a:p>
-          <a:p>
-            <a:pPr>
-              <a:defRPr sz="3600" b="1">
+          <a:p/>
+          <a:p>
+            <a:pPr>
+              <a:defRPr b="1" sz="3600">
                 <a:solidFill>
                   <a:srgbClr val="111827"/>
                 </a:solidFill>
@@ -9383,41 +9231,11 @@
                 <a:tableStyleId>{5C22544A-7EE6-4342-B048-85BDC9FD1C3A}</a:tableStyleId>
               </a:tblPr>
               <a:tblGrid>
-                <a:gridCol w="2254910">
-                  <a:extLst>
-                    <a:ext uri="{9D8B030D-6E8A-4147-A177-3AD203B41FA5}">
-                      <a16:colId xmlns:a16="http://schemas.microsoft.com/office/drawing/2014/main" val="20000"/>
-                    </a:ext>
-                  </a:extLst>
-                </a:gridCol>
-                <a:gridCol w="2254910">
-                  <a:extLst>
-                    <a:ext uri="{9D8B030D-6E8A-4147-A177-3AD203B41FA5}">
-                      <a16:colId xmlns:a16="http://schemas.microsoft.com/office/drawing/2014/main" val="20001"/>
-                    </a:ext>
-                  </a:extLst>
-                </a:gridCol>
-                <a:gridCol w="2254910">
-                  <a:extLst>
-                    <a:ext uri="{9D8B030D-6E8A-4147-A177-3AD203B41FA5}">
-                      <a16:colId xmlns:a16="http://schemas.microsoft.com/office/drawing/2014/main" val="20002"/>
-                    </a:ext>
-                  </a:extLst>
-                </a:gridCol>
-                <a:gridCol w="2254910">
-                  <a:extLst>
-                    <a:ext uri="{9D8B030D-6E8A-4147-A177-3AD203B41FA5}">
-                      <a16:colId xmlns:a16="http://schemas.microsoft.com/office/drawing/2014/main" val="20003"/>
-                    </a:ext>
-                  </a:extLst>
-                </a:gridCol>
-                <a:gridCol w="2254912">
-                  <a:extLst>
-                    <a:ext uri="{9D8B030D-6E8A-4147-A177-3AD203B41FA5}">
-                      <a16:colId xmlns:a16="http://schemas.microsoft.com/office/drawing/2014/main" val="20004"/>
-                    </a:ext>
-                  </a:extLst>
-                </a:gridCol>
+                <a:gridCol w="2254910"/>
+                <a:gridCol w="2254910"/>
+                <a:gridCol w="2254910"/>
+                <a:gridCol w="2254910"/>
+                <a:gridCol w="2254912"/>
               </a:tblGrid>
               <a:tr h="1143000">
                 <a:tc>
@@ -9426,7 +9244,7 @@
                     <a:lstStyle/>
                     <a:p>
                       <a:pPr>
-                        <a:defRPr sz="1400" b="1">
+                        <a:defRPr b="1" sz="1400">
                           <a:solidFill>
                             <a:srgbClr val="FFFFFF"/>
                           </a:solidFill>
@@ -9449,7 +9267,7 @@
                     <a:lstStyle/>
                     <a:p>
                       <a:pPr>
-                        <a:defRPr sz="1400" b="1">
+                        <a:defRPr b="1" sz="1400">
                           <a:solidFill>
                             <a:srgbClr val="FFFFFF"/>
                           </a:solidFill>
@@ -9472,7 +9290,7 @@
                     <a:lstStyle/>
                     <a:p>
                       <a:pPr>
-                        <a:defRPr sz="1400" b="1">
+                        <a:defRPr b="1" sz="1400">
                           <a:solidFill>
                             <a:srgbClr val="FFFFFF"/>
                           </a:solidFill>
@@ -9495,7 +9313,7 @@
                     <a:lstStyle/>
                     <a:p>
                       <a:pPr>
-                        <a:defRPr sz="1400" b="1">
+                        <a:defRPr b="1" sz="1400">
                           <a:solidFill>
                             <a:srgbClr val="FFFFFF"/>
                           </a:solidFill>
@@ -9518,7 +9336,7 @@
                     <a:lstStyle/>
                     <a:p>
                       <a:pPr>
-                        <a:defRPr sz="1400" b="1">
+                        <a:defRPr b="1" sz="1400">
                           <a:solidFill>
                             <a:srgbClr val="FFFFFF"/>
                           </a:solidFill>
@@ -9535,11 +9353,6 @@
                     </a:solidFill>
                   </a:tcPr>
                 </a:tc>
-                <a:extLst>
-                  <a:ext uri="{0D108BD9-81ED-4DB2-BD59-A6C34878D82A}">
-                    <a16:rowId xmlns:a16="http://schemas.microsoft.com/office/drawing/2014/main" val="10000"/>
-                  </a:ext>
-                </a:extLst>
               </a:tr>
               <a:tr h="1143000">
                 <a:tc>
@@ -9637,11 +9450,6 @@
                   </a:txBody>
                   <a:tcPr/>
                 </a:tc>
-                <a:extLst>
-                  <a:ext uri="{0D108BD9-81ED-4DB2-BD59-A6C34878D82A}">
-                    <a16:rowId xmlns:a16="http://schemas.microsoft.com/office/drawing/2014/main" val="10001"/>
-                  </a:ext>
-                </a:extLst>
               </a:tr>
               <a:tr h="1143000">
                 <a:tc>
@@ -9739,11 +9547,6 @@
                   </a:txBody>
                   <a:tcPr/>
                 </a:tc>
-                <a:extLst>
-                  <a:ext uri="{0D108BD9-81ED-4DB2-BD59-A6C34878D82A}">
-                    <a16:rowId xmlns:a16="http://schemas.microsoft.com/office/drawing/2014/main" val="10002"/>
-                  </a:ext>
-                </a:extLst>
               </a:tr>
               <a:tr h="1143000">
                 <a:tc>
@@ -9841,11 +9644,6 @@
                   </a:txBody>
                   <a:tcPr/>
                 </a:tc>
-                <a:extLst>
-                  <a:ext uri="{0D108BD9-81ED-4DB2-BD59-A6C34878D82A}">
-                    <a16:rowId xmlns:a16="http://schemas.microsoft.com/office/drawing/2014/main" val="10003"/>
-                  </a:ext>
-                </a:extLst>
               </a:tr>
             </a:tbl>
           </a:graphicData>
@@ -9860,7 +9658,7 @@
 </file>
 
 <file path=ppt/slides/slide7.xml><?xml version="1.0" encoding="utf-8"?>
-<p:sld xmlns:a="http://schemas.openxmlformats.org/drawingml/2006/main" xmlns:r="http://schemas.openxmlformats.org/officeDocument/2006/relationships" xmlns:p="http://schemas.openxmlformats.org/presentationml/2006/main">
+<p:sld xmlns:a="http://schemas.openxmlformats.org/drawingml/2006/main" xmlns:p="http://schemas.openxmlformats.org/presentationml/2006/main" xmlns:r="http://schemas.openxmlformats.org/officeDocument/2006/relationships">
   <p:cSld>
     <p:spTree>
       <p:nvGrpSpPr>
@@ -9868,14 +9666,7 @@
         <p:cNvGrpSpPr/>
         <p:nvPr/>
       </p:nvGrpSpPr>
-      <p:grpSpPr>
-        <a:xfrm>
-          <a:off x="0" y="0"/>
-          <a:ext cx="0" cy="0"/>
-          <a:chOff x="0" y="0"/>
-          <a:chExt cx="0" cy="0"/>
-        </a:xfrm>
-      </p:grpSpPr>
+      <p:grpSpPr/>
       <p:sp>
         <p:nvSpPr>
           <p:cNvPr id="2" name="TextBox 1"/>
@@ -9897,9 +9688,7 @@
             <a:spAutoFit/>
           </a:bodyPr>
           <a:lstStyle/>
-          <a:p>
-            <a:endParaRPr/>
-          </a:p>
+          <a:p/>
           <a:p>
             <a:pPr>
               <a:defRPr sz="1000">
@@ -9935,12 +9724,10 @@
             <a:spAutoFit/>
           </a:bodyPr>
           <a:lstStyle/>
-          <a:p>
-            <a:endParaRPr/>
-          </a:p>
-          <a:p>
-            <a:pPr>
-              <a:defRPr sz="3600" b="1">
+          <a:p/>
+          <a:p>
+            <a:pPr>
+              <a:defRPr b="1" sz="3600">
                 <a:solidFill>
                   <a:srgbClr val="111827"/>
                 </a:solidFill>
@@ -9971,41 +9758,11 @@
                 <a:tableStyleId>{5C22544A-7EE6-4342-B048-85BDC9FD1C3A}</a:tableStyleId>
               </a:tblPr>
               <a:tblGrid>
-                <a:gridCol w="2254910">
-                  <a:extLst>
-                    <a:ext uri="{9D8B030D-6E8A-4147-A177-3AD203B41FA5}">
-                      <a16:colId xmlns:a16="http://schemas.microsoft.com/office/drawing/2014/main" val="20000"/>
-                    </a:ext>
-                  </a:extLst>
-                </a:gridCol>
-                <a:gridCol w="2254910">
-                  <a:extLst>
-                    <a:ext uri="{9D8B030D-6E8A-4147-A177-3AD203B41FA5}">
-                      <a16:colId xmlns:a16="http://schemas.microsoft.com/office/drawing/2014/main" val="20001"/>
-                    </a:ext>
-                  </a:extLst>
-                </a:gridCol>
-                <a:gridCol w="2254910">
-                  <a:extLst>
-                    <a:ext uri="{9D8B030D-6E8A-4147-A177-3AD203B41FA5}">
-                      <a16:colId xmlns:a16="http://schemas.microsoft.com/office/drawing/2014/main" val="20002"/>
-                    </a:ext>
-                  </a:extLst>
-                </a:gridCol>
-                <a:gridCol w="2254910">
-                  <a:extLst>
-                    <a:ext uri="{9D8B030D-6E8A-4147-A177-3AD203B41FA5}">
-                      <a16:colId xmlns:a16="http://schemas.microsoft.com/office/drawing/2014/main" val="20003"/>
-                    </a:ext>
-                  </a:extLst>
-                </a:gridCol>
-                <a:gridCol w="2254912">
-                  <a:extLst>
-                    <a:ext uri="{9D8B030D-6E8A-4147-A177-3AD203B41FA5}">
-                      <a16:colId xmlns:a16="http://schemas.microsoft.com/office/drawing/2014/main" val="20004"/>
-                    </a:ext>
-                  </a:extLst>
-                </a:gridCol>
+                <a:gridCol w="2254910"/>
+                <a:gridCol w="2254910"/>
+                <a:gridCol w="2254910"/>
+                <a:gridCol w="2254910"/>
+                <a:gridCol w="2254912"/>
               </a:tblGrid>
               <a:tr h="1143000">
                 <a:tc>
@@ -10014,7 +9771,7 @@
                     <a:lstStyle/>
                     <a:p>
                       <a:pPr>
-                        <a:defRPr sz="1400" b="1">
+                        <a:defRPr b="1" sz="1400">
                           <a:solidFill>
                             <a:srgbClr val="FFFFFF"/>
                           </a:solidFill>
@@ -10037,7 +9794,7 @@
                     <a:lstStyle/>
                     <a:p>
                       <a:pPr>
-                        <a:defRPr sz="1400" b="1">
+                        <a:defRPr b="1" sz="1400">
                           <a:solidFill>
                             <a:srgbClr val="FFFFFF"/>
                           </a:solidFill>
@@ -10060,7 +9817,7 @@
                     <a:lstStyle/>
                     <a:p>
                       <a:pPr>
-                        <a:defRPr sz="1400" b="1">
+                        <a:defRPr b="1" sz="1400">
                           <a:solidFill>
                             <a:srgbClr val="FFFFFF"/>
                           </a:solidFill>
@@ -10083,7 +9840,7 @@
                     <a:lstStyle/>
                     <a:p>
                       <a:pPr>
-                        <a:defRPr sz="1400" b="1">
+                        <a:defRPr b="1" sz="1400">
                           <a:solidFill>
                             <a:srgbClr val="FFFFFF"/>
                           </a:solidFill>
@@ -10106,7 +9863,7 @@
                     <a:lstStyle/>
                     <a:p>
                       <a:pPr>
-                        <a:defRPr sz="1400" b="1">
+                        <a:defRPr b="1" sz="1400">
                           <a:solidFill>
                             <a:srgbClr val="FFFFFF"/>
                           </a:solidFill>
@@ -10123,11 +9880,6 @@
                     </a:solidFill>
                   </a:tcPr>
                 </a:tc>
-                <a:extLst>
-                  <a:ext uri="{0D108BD9-81ED-4DB2-BD59-A6C34878D82A}">
-                    <a16:rowId xmlns:a16="http://schemas.microsoft.com/office/drawing/2014/main" val="10000"/>
-                  </a:ext>
-                </a:extLst>
               </a:tr>
               <a:tr h="1143000">
                 <a:tc>
@@ -10225,11 +9977,6 @@
                   </a:txBody>
                   <a:tcPr/>
                 </a:tc>
-                <a:extLst>
-                  <a:ext uri="{0D108BD9-81ED-4DB2-BD59-A6C34878D82A}">
-                    <a16:rowId xmlns:a16="http://schemas.microsoft.com/office/drawing/2014/main" val="10001"/>
-                  </a:ext>
-                </a:extLst>
               </a:tr>
               <a:tr h="1143000">
                 <a:tc>
@@ -10327,11 +10074,6 @@
                   </a:txBody>
                   <a:tcPr/>
                 </a:tc>
-                <a:extLst>
-                  <a:ext uri="{0D108BD9-81ED-4DB2-BD59-A6C34878D82A}">
-                    <a16:rowId xmlns:a16="http://schemas.microsoft.com/office/drawing/2014/main" val="10002"/>
-                  </a:ext>
-                </a:extLst>
               </a:tr>
               <a:tr h="1143000">
                 <a:tc>
@@ -10429,11 +10171,6 @@
                   </a:txBody>
                   <a:tcPr/>
                 </a:tc>
-                <a:extLst>
-                  <a:ext uri="{0D108BD9-81ED-4DB2-BD59-A6C34878D82A}">
-                    <a16:rowId xmlns:a16="http://schemas.microsoft.com/office/drawing/2014/main" val="10003"/>
-                  </a:ext>
-                </a:extLst>
               </a:tr>
             </a:tbl>
           </a:graphicData>
@@ -10448,7 +10185,7 @@
 </file>
 
 <file path=ppt/slides/slide8.xml><?xml version="1.0" encoding="utf-8"?>
-<p:sld xmlns:a="http://schemas.openxmlformats.org/drawingml/2006/main" xmlns:r="http://schemas.openxmlformats.org/officeDocument/2006/relationships" xmlns:p="http://schemas.openxmlformats.org/presentationml/2006/main">
+<p:sld xmlns:a="http://schemas.openxmlformats.org/drawingml/2006/main" xmlns:p="http://schemas.openxmlformats.org/presentationml/2006/main" xmlns:r="http://schemas.openxmlformats.org/officeDocument/2006/relationships">
   <p:cSld>
     <p:spTree>
       <p:nvGrpSpPr>
@@ -10456,14 +10193,7 @@
         <p:cNvGrpSpPr/>
         <p:nvPr/>
       </p:nvGrpSpPr>
-      <p:grpSpPr>
-        <a:xfrm>
-          <a:off x="0" y="0"/>
-          <a:ext cx="0" cy="0"/>
-          <a:chOff x="0" y="0"/>
-          <a:chExt cx="0" cy="0"/>
-        </a:xfrm>
-      </p:grpSpPr>
+      <p:grpSpPr/>
       <p:sp>
         <p:nvSpPr>
           <p:cNvPr id="2" name="TextBox 1"/>
@@ -10485,9 +10215,7 @@
             <a:spAutoFit/>
           </a:bodyPr>
           <a:lstStyle/>
-          <a:p>
-            <a:endParaRPr/>
-          </a:p>
+          <a:p/>
           <a:p>
             <a:pPr>
               <a:defRPr sz="1000">
@@ -10523,12 +10251,10 @@
             <a:spAutoFit/>
           </a:bodyPr>
           <a:lstStyle/>
-          <a:p>
-            <a:endParaRPr/>
-          </a:p>
-          <a:p>
-            <a:pPr>
-              <a:defRPr sz="3600" b="1">
+          <a:p/>
+          <a:p>
+            <a:pPr>
+              <a:defRPr b="1" sz="3600">
                 <a:solidFill>
                   <a:srgbClr val="111827"/>
                 </a:solidFill>
@@ -10559,41 +10285,11 @@
                 <a:tableStyleId>{5C22544A-7EE6-4342-B048-85BDC9FD1C3A}</a:tableStyleId>
               </a:tblPr>
               <a:tblGrid>
-                <a:gridCol w="2254910">
-                  <a:extLst>
-                    <a:ext uri="{9D8B030D-6E8A-4147-A177-3AD203B41FA5}">
-                      <a16:colId xmlns:a16="http://schemas.microsoft.com/office/drawing/2014/main" val="20000"/>
-                    </a:ext>
-                  </a:extLst>
-                </a:gridCol>
-                <a:gridCol w="2254910">
-                  <a:extLst>
-                    <a:ext uri="{9D8B030D-6E8A-4147-A177-3AD203B41FA5}">
-                      <a16:colId xmlns:a16="http://schemas.microsoft.com/office/drawing/2014/main" val="20001"/>
-                    </a:ext>
-                  </a:extLst>
-                </a:gridCol>
-                <a:gridCol w="2254910">
-                  <a:extLst>
-                    <a:ext uri="{9D8B030D-6E8A-4147-A177-3AD203B41FA5}">
-                      <a16:colId xmlns:a16="http://schemas.microsoft.com/office/drawing/2014/main" val="20002"/>
-                    </a:ext>
-                  </a:extLst>
-                </a:gridCol>
-                <a:gridCol w="2254910">
-                  <a:extLst>
-                    <a:ext uri="{9D8B030D-6E8A-4147-A177-3AD203B41FA5}">
-                      <a16:colId xmlns:a16="http://schemas.microsoft.com/office/drawing/2014/main" val="20003"/>
-                    </a:ext>
-                  </a:extLst>
-                </a:gridCol>
-                <a:gridCol w="2254912">
-                  <a:extLst>
-                    <a:ext uri="{9D8B030D-6E8A-4147-A177-3AD203B41FA5}">
-                      <a16:colId xmlns:a16="http://schemas.microsoft.com/office/drawing/2014/main" val="20004"/>
-                    </a:ext>
-                  </a:extLst>
-                </a:gridCol>
+                <a:gridCol w="2254910"/>
+                <a:gridCol w="2254910"/>
+                <a:gridCol w="2254910"/>
+                <a:gridCol w="2254910"/>
+                <a:gridCol w="2254912"/>
               </a:tblGrid>
               <a:tr h="1143000">
                 <a:tc>
@@ -10602,7 +10298,7 @@
                     <a:lstStyle/>
                     <a:p>
                       <a:pPr>
-                        <a:defRPr sz="1400" b="1">
+                        <a:defRPr b="1" sz="1400">
                           <a:solidFill>
                             <a:srgbClr val="FFFFFF"/>
                           </a:solidFill>
@@ -10625,7 +10321,7 @@
                     <a:lstStyle/>
                     <a:p>
                       <a:pPr>
-                        <a:defRPr sz="1400" b="1">
+                        <a:defRPr b="1" sz="1400">
                           <a:solidFill>
                             <a:srgbClr val="FFFFFF"/>
                           </a:solidFill>
@@ -10648,7 +10344,7 @@
                     <a:lstStyle/>
                     <a:p>
                       <a:pPr>
-                        <a:defRPr sz="1400" b="1">
+                        <a:defRPr b="1" sz="1400">
                           <a:solidFill>
                             <a:srgbClr val="FFFFFF"/>
                           </a:solidFill>
@@ -10671,7 +10367,7 @@
                     <a:lstStyle/>
                     <a:p>
                       <a:pPr>
-                        <a:defRPr sz="1400" b="1">
+                        <a:defRPr b="1" sz="1400">
                           <a:solidFill>
                             <a:srgbClr val="FFFFFF"/>
                           </a:solidFill>
@@ -10694,7 +10390,7 @@
                     <a:lstStyle/>
                     <a:p>
                       <a:pPr>
-                        <a:defRPr sz="1400" b="1">
+                        <a:defRPr b="1" sz="1400">
                           <a:solidFill>
                             <a:srgbClr val="FFFFFF"/>
                           </a:solidFill>
@@ -10711,11 +10407,6 @@
                     </a:solidFill>
                   </a:tcPr>
                 </a:tc>
-                <a:extLst>
-                  <a:ext uri="{0D108BD9-81ED-4DB2-BD59-A6C34878D82A}">
-                    <a16:rowId xmlns:a16="http://schemas.microsoft.com/office/drawing/2014/main" val="10000"/>
-                  </a:ext>
-                </a:extLst>
               </a:tr>
               <a:tr h="1143000">
                 <a:tc>
@@ -10813,11 +10504,6 @@
                   </a:txBody>
                   <a:tcPr/>
                 </a:tc>
-                <a:extLst>
-                  <a:ext uri="{0D108BD9-81ED-4DB2-BD59-A6C34878D82A}">
-                    <a16:rowId xmlns:a16="http://schemas.microsoft.com/office/drawing/2014/main" val="10001"/>
-                  </a:ext>
-                </a:extLst>
               </a:tr>
               <a:tr h="1143000">
                 <a:tc>
@@ -10915,11 +10601,6 @@
                   </a:txBody>
                   <a:tcPr/>
                 </a:tc>
-                <a:extLst>
-                  <a:ext uri="{0D108BD9-81ED-4DB2-BD59-A6C34878D82A}">
-                    <a16:rowId xmlns:a16="http://schemas.microsoft.com/office/drawing/2014/main" val="10002"/>
-                  </a:ext>
-                </a:extLst>
               </a:tr>
               <a:tr h="1143000">
                 <a:tc>
@@ -11017,11 +10698,6 @@
                   </a:txBody>
                   <a:tcPr/>
                 </a:tc>
-                <a:extLst>
-                  <a:ext uri="{0D108BD9-81ED-4DB2-BD59-A6C34878D82A}">
-                    <a16:rowId xmlns:a16="http://schemas.microsoft.com/office/drawing/2014/main" val="10003"/>
-                  </a:ext>
-                </a:extLst>
               </a:tr>
             </a:tbl>
           </a:graphicData>
@@ -11036,7 +10712,7 @@
 </file>
 
 <file path=ppt/slides/slide9.xml><?xml version="1.0" encoding="utf-8"?>
-<p:sld xmlns:a="http://schemas.openxmlformats.org/drawingml/2006/main" xmlns:r="http://schemas.openxmlformats.org/officeDocument/2006/relationships" xmlns:p="http://schemas.openxmlformats.org/presentationml/2006/main">
+<p:sld xmlns:a="http://schemas.openxmlformats.org/drawingml/2006/main" xmlns:p="http://schemas.openxmlformats.org/presentationml/2006/main" xmlns:r="http://schemas.openxmlformats.org/officeDocument/2006/relationships">
   <p:cSld>
     <p:spTree>
       <p:nvGrpSpPr>
@@ -11044,14 +10720,7 @@
         <p:cNvGrpSpPr/>
         <p:nvPr/>
       </p:nvGrpSpPr>
-      <p:grpSpPr>
-        <a:xfrm>
-          <a:off x="0" y="0"/>
-          <a:ext cx="0" cy="0"/>
-          <a:chOff x="0" y="0"/>
-          <a:chExt cx="0" cy="0"/>
-        </a:xfrm>
-      </p:grpSpPr>
+      <p:grpSpPr/>
       <p:sp>
         <p:nvSpPr>
           <p:cNvPr id="2" name="TextBox 1"/>
@@ -11073,9 +10742,7 @@
             <a:spAutoFit/>
           </a:bodyPr>
           <a:lstStyle/>
-          <a:p>
-            <a:endParaRPr/>
-          </a:p>
+          <a:p/>
           <a:p>
             <a:pPr>
               <a:defRPr sz="1000">
@@ -11111,12 +10778,10 @@
             <a:spAutoFit/>
           </a:bodyPr>
           <a:lstStyle/>
-          <a:p>
-            <a:endParaRPr/>
-          </a:p>
-          <a:p>
-            <a:pPr>
-              <a:defRPr sz="3600" b="1">
+          <a:p/>
+          <a:p>
+            <a:pPr>
+              <a:defRPr b="1" sz="3600">
                 <a:solidFill>
                   <a:srgbClr val="111827"/>
                 </a:solidFill>
@@ -11184,12 +10849,10 @@
             <a:spAutoFit/>
           </a:bodyPr>
           <a:lstStyle/>
-          <a:p>
-            <a:endParaRPr/>
-          </a:p>
-          <a:p>
-            <a:pPr>
-              <a:defRPr sz="1800" b="1">
+          <a:p/>
+          <a:p>
+            <a:pPr>
+              <a:defRPr b="1" sz="1800">
                 <a:solidFill>
                   <a:srgbClr val="DC2626"/>
                 </a:solidFill>
@@ -11284,12 +10947,10 @@
             <a:spAutoFit/>
           </a:bodyPr>
           <a:lstStyle/>
-          <a:p>
-            <a:endParaRPr/>
-          </a:p>
+          <a:p/>
           <a:p>
             <a:pPr algn="ctr">
-              <a:defRPr sz="2000" b="1">
+              <a:defRPr b="1" sz="2000">
                 <a:solidFill>
                   <a:srgbClr val="2563EB"/>
                 </a:solidFill>
@@ -11655,44 +11316,44 @@
         <a:sysClr val="window" lastClr="FFFFFF"/>
       </a:lt1>
       <a:dk2>
-        <a:srgbClr val="0E2841"/>
+        <a:srgbClr val="1F497D"/>
       </a:dk2>
       <a:lt2>
-        <a:srgbClr val="E8E8E8"/>
+        <a:srgbClr val="EEECE1"/>
       </a:lt2>
       <a:accent1>
-        <a:srgbClr val="156082"/>
+        <a:srgbClr val="4F81BD"/>
       </a:accent1>
       <a:accent2>
-        <a:srgbClr val="E97132"/>
+        <a:srgbClr val="C0504D"/>
       </a:accent2>
       <a:accent3>
-        <a:srgbClr val="196B24"/>
+        <a:srgbClr val="9BBB59"/>
       </a:accent3>
       <a:accent4>
-        <a:srgbClr val="0F9ED5"/>
+        <a:srgbClr val="8064A2"/>
       </a:accent4>
       <a:accent5>
-        <a:srgbClr val="A02B93"/>
+        <a:srgbClr val="4BACC6"/>
       </a:accent5>
       <a:accent6>
-        <a:srgbClr val="4EA72E"/>
+        <a:srgbClr val="F79646"/>
       </a:accent6>
       <a:hlink>
-        <a:srgbClr val="467886"/>
+        <a:srgbClr val="0000FF"/>
       </a:hlink>
       <a:folHlink>
-        <a:srgbClr val="96607D"/>
+        <a:srgbClr val="800080"/>
       </a:folHlink>
     </a:clrScheme>
     <a:fontScheme name="Office">
       <a:majorFont>
-        <a:latin typeface="Aptos Display" panose="02110004020202020204"/>
+        <a:latin typeface="Calibri"/>
         <a:ea typeface=""/>
         <a:cs typeface=""/>
-        <a:font script="Jpan" typeface="游ゴシック Light"/>
+        <a:font script="Jpan" typeface="ＭＳ Ｐゴシック"/>
         <a:font script="Hang" typeface="맑은 고딕"/>
-        <a:font script="Hans" typeface="等线 Light"/>
+        <a:font script="Hans" typeface="宋体"/>
         <a:font script="Hant" typeface="新細明體"/>
         <a:font script="Arab" typeface="Times New Roman"/>
         <a:font script="Hebr" typeface="Times New Roman"/>
@@ -11720,31 +11381,14 @@
         <a:font script="Viet" typeface="Times New Roman"/>
         <a:font script="Uigh" typeface="Microsoft Uighur"/>
         <a:font script="Geor" typeface="Sylfaen"/>
-        <a:font script="Armn" typeface="Arial"/>
-        <a:font script="Bugi" typeface="Leelawadee UI"/>
-        <a:font script="Bopo" typeface="Microsoft JhengHei"/>
-        <a:font script="Java" typeface="Javanese Text"/>
-        <a:font script="Lisu" typeface="Segoe UI"/>
-        <a:font script="Mymr" typeface="Myanmar Text"/>
-        <a:font script="Nkoo" typeface="Ebrima"/>
-        <a:font script="Olck" typeface="Nirmala UI"/>
-        <a:font script="Osma" typeface="Ebrima"/>
-        <a:font script="Phag" typeface="Phagspa"/>
-        <a:font script="Syrn" typeface="Estrangelo Edessa"/>
-        <a:font script="Syrj" typeface="Estrangelo Edessa"/>
-        <a:font script="Syre" typeface="Estrangelo Edessa"/>
-        <a:font script="Sora" typeface="Nirmala UI"/>
-        <a:font script="Tale" typeface="Microsoft Tai Le"/>
-        <a:font script="Talu" typeface="Microsoft New Tai Lue"/>
-        <a:font script="Tfng" typeface="Ebrima"/>
       </a:majorFont>
       <a:minorFont>
-        <a:latin typeface="Aptos" panose="02110004020202020204"/>
+        <a:latin typeface="Calibri"/>
         <a:ea typeface=""/>
         <a:cs typeface=""/>
-        <a:font script="Jpan" typeface="游ゴシック"/>
+        <a:font script="Jpan" typeface="ＭＳ Ｐゴシック"/>
         <a:font script="Hang" typeface="맑은 고딕"/>
-        <a:font script="Hans" typeface="等线"/>
+        <a:font script="Hans" typeface="宋体"/>
         <a:font script="Hant" typeface="新細明體"/>
         <a:font script="Arab" typeface="Arial"/>
         <a:font script="Hebr" typeface="Arial"/>
@@ -11772,23 +11416,6 @@
         <a:font script="Viet" typeface="Arial"/>
         <a:font script="Uigh" typeface="Microsoft Uighur"/>
         <a:font script="Geor" typeface="Sylfaen"/>
-        <a:font script="Armn" typeface="Arial"/>
-        <a:font script="Bugi" typeface="Leelawadee UI"/>
-        <a:font script="Bopo" typeface="Microsoft JhengHei"/>
-        <a:font script="Java" typeface="Javanese Text"/>
-        <a:font script="Lisu" typeface="Segoe UI"/>
-        <a:font script="Mymr" typeface="Myanmar Text"/>
-        <a:font script="Nkoo" typeface="Ebrima"/>
-        <a:font script="Olck" typeface="Nirmala UI"/>
-        <a:font script="Osma" typeface="Ebrima"/>
-        <a:font script="Phag" typeface="Phagspa"/>
-        <a:font script="Syrn" typeface="Estrangelo Edessa"/>
-        <a:font script="Syrj" typeface="Estrangelo Edessa"/>
-        <a:font script="Syre" typeface="Estrangelo Edessa"/>
-        <a:font script="Sora" typeface="Nirmala UI"/>
-        <a:font script="Tale" typeface="Microsoft Tai Le"/>
-        <a:font script="Talu" typeface="Microsoft New Tai Lue"/>
-        <a:font script="Tfng" typeface="Ebrima"/>
       </a:minorFont>
     </a:fontScheme>
     <a:fmtScheme name="Office">
@@ -11800,136 +11427,180 @@
           <a:gsLst>
             <a:gs pos="0">
               <a:schemeClr val="phClr">
-                <a:lumMod val="110000"/>
-                <a:satMod val="105000"/>
-                <a:tint val="67000"/>
+                <a:tint val="50000"/>
+                <a:satMod val="300000"/>
               </a:schemeClr>
             </a:gs>
-            <a:gs pos="50000">
+            <a:gs pos="35000">
               <a:schemeClr val="phClr">
-                <a:lumMod val="105000"/>
-                <a:satMod val="103000"/>
-                <a:tint val="73000"/>
+                <a:tint val="37000"/>
+                <a:satMod val="300000"/>
               </a:schemeClr>
             </a:gs>
             <a:gs pos="100000">
               <a:schemeClr val="phClr">
-                <a:lumMod val="105000"/>
-                <a:satMod val="109000"/>
-                <a:tint val="81000"/>
+                <a:tint val="15000"/>
+                <a:satMod val="350000"/>
               </a:schemeClr>
             </a:gs>
           </a:gsLst>
-          <a:lin ang="5400000" scaled="0"/>
+          <a:lin ang="16200000" scaled="1"/>
         </a:gradFill>
         <a:gradFill rotWithShape="1">
           <a:gsLst>
             <a:gs pos="0">
               <a:schemeClr val="phClr">
-                <a:satMod val="103000"/>
-                <a:lumMod val="102000"/>
-                <a:tint val="94000"/>
-              </a:schemeClr>
-            </a:gs>
-            <a:gs pos="50000">
-              <a:schemeClr val="phClr">
-                <a:satMod val="110000"/>
-                <a:lumMod val="100000"/>
+                <a:tint val="100000"/>
                 <a:shade val="100000"/>
+                <a:satMod val="130000"/>
               </a:schemeClr>
             </a:gs>
             <a:gs pos="100000">
               <a:schemeClr val="phClr">
-                <a:lumMod val="99000"/>
-                <a:satMod val="120000"/>
-                <a:shade val="78000"/>
+                <a:tint val="50000"/>
+                <a:shade val="100000"/>
+                <a:satMod val="350000"/>
               </a:schemeClr>
             </a:gs>
           </a:gsLst>
-          <a:lin ang="5400000" scaled="0"/>
+          <a:lin ang="16200000" scaled="0"/>
         </a:gradFill>
       </a:fillStyleLst>
       <a:lnStyleLst>
-        <a:ln w="12700" cap="flat" cmpd="sng" algn="ctr">
+        <a:ln w="9525" cap="flat" cmpd="sng" algn="ctr">
           <a:solidFill>
-            <a:schemeClr val="phClr"/>
+            <a:schemeClr val="phClr">
+              <a:shade val="95000"/>
+              <a:satMod val="105000"/>
+            </a:schemeClr>
           </a:solidFill>
           <a:prstDash val="solid"/>
-          <a:miter lim="800000"/>
-        </a:ln>
-        <a:ln w="19050" cap="flat" cmpd="sng" algn="ctr">
-          <a:solidFill>
-            <a:schemeClr val="phClr"/>
-          </a:solidFill>
-          <a:prstDash val="solid"/>
-          <a:miter lim="800000"/>
         </a:ln>
         <a:ln w="25400" cap="flat" cmpd="sng" algn="ctr">
           <a:solidFill>
             <a:schemeClr val="phClr"/>
           </a:solidFill>
           <a:prstDash val="solid"/>
-          <a:miter lim="800000"/>
+        </a:ln>
+        <a:ln w="38100" cap="flat" cmpd="sng" algn="ctr">
+          <a:solidFill>
+            <a:schemeClr val="phClr"/>
+          </a:solidFill>
+          <a:prstDash val="solid"/>
         </a:ln>
       </a:lnStyleLst>
       <a:effectStyleLst>
         <a:effectStyle>
-          <a:effectLst/>
-        </a:effectStyle>
-        <a:effectStyle>
-          <a:effectLst/>
+          <a:effectLst>
+            <a:outerShdw blurRad="40000" dist="20000" dir="5400000" rotWithShape="0">
+              <a:srgbClr val="000000">
+                <a:alpha val="38000"/>
+              </a:srgbClr>
+            </a:outerShdw>
+          </a:effectLst>
         </a:effectStyle>
         <a:effectStyle>
           <a:effectLst>
-            <a:outerShdw blurRad="57150" dist="19050" dir="5400000" algn="ctr" rotWithShape="0">
+            <a:outerShdw blurRad="40000" dist="23000" dir="5400000" rotWithShape="0">
               <a:srgbClr val="000000">
-                <a:alpha val="63000"/>
+                <a:alpha val="35000"/>
               </a:srgbClr>
             </a:outerShdw>
           </a:effectLst>
+        </a:effectStyle>
+        <a:effectStyle>
+          <a:effectLst>
+            <a:outerShdw blurRad="40000" dist="23000" dir="5400000" rotWithShape="0">
+              <a:srgbClr val="000000">
+                <a:alpha val="35000"/>
+              </a:srgbClr>
+            </a:outerShdw>
+          </a:effectLst>
+          <a:scene3d>
+            <a:camera prst="orthographicFront">
+              <a:rot lat="0" lon="0" rev="0"/>
+            </a:camera>
+            <a:lightRig rig="threePt" dir="t">
+              <a:rot lat="0" lon="0" rev="1200000"/>
+            </a:lightRig>
+          </a:scene3d>
+          <a:sp3d>
+            <a:bevelT w="63500" h="25400"/>
+          </a:sp3d>
         </a:effectStyle>
       </a:effectStyleLst>
       <a:bgFillStyleLst>
         <a:solidFill>
           <a:schemeClr val="phClr"/>
         </a:solidFill>
-        <a:solidFill>
-          <a:schemeClr val="phClr">
-            <a:tint val="95000"/>
-            <a:satMod val="170000"/>
-          </a:schemeClr>
-        </a:solidFill>
         <a:gradFill rotWithShape="1">
           <a:gsLst>
             <a:gs pos="0">
               <a:schemeClr val="phClr">
-                <a:tint val="93000"/>
-                <a:satMod val="150000"/>
-                <a:shade val="98000"/>
-                <a:lumMod val="102000"/>
+                <a:tint val="40000"/>
+                <a:satMod val="350000"/>
               </a:schemeClr>
             </a:gs>
-            <a:gs pos="50000">
+            <a:gs pos="40000">
               <a:schemeClr val="phClr">
-                <a:tint val="98000"/>
-                <a:satMod val="130000"/>
-                <a:shade val="90000"/>
-                <a:lumMod val="103000"/>
+                <a:tint val="45000"/>
+                <a:shade val="99000"/>
+                <a:satMod val="350000"/>
               </a:schemeClr>
             </a:gs>
             <a:gs pos="100000">
               <a:schemeClr val="phClr">
-                <a:shade val="63000"/>
-                <a:satMod val="120000"/>
+                <a:shade val="20000"/>
+                <a:satMod val="255000"/>
               </a:schemeClr>
             </a:gs>
           </a:gsLst>
-          <a:lin ang="5400000" scaled="0"/>
+          <a:path path="circle">
+            <a:fillToRect l="50000" t="-80000" r="50000" b="180000"/>
+          </a:path>
+        </a:gradFill>
+        <a:gradFill rotWithShape="1">
+          <a:gsLst>
+            <a:gs pos="0">
+              <a:schemeClr val="phClr">
+                <a:tint val="80000"/>
+                <a:satMod val="300000"/>
+              </a:schemeClr>
+            </a:gs>
+            <a:gs pos="100000">
+              <a:schemeClr val="phClr">
+                <a:shade val="30000"/>
+                <a:satMod val="200000"/>
+              </a:schemeClr>
+            </a:gs>
+          </a:gsLst>
+          <a:path path="circle">
+            <a:fillToRect l="50000" t="50000" r="50000" b="50000"/>
+          </a:path>
         </a:gradFill>
       </a:bgFillStyleLst>
     </a:fmtScheme>
   </a:themeElements>
   <a:objectDefaults>
+    <a:spDef>
+      <a:spPr/>
+      <a:bodyPr/>
+      <a:lstStyle/>
+      <a:style>
+        <a:lnRef idx="1">
+          <a:schemeClr val="accent1"/>
+        </a:lnRef>
+        <a:fillRef idx="3">
+          <a:schemeClr val="accent1"/>
+        </a:fillRef>
+        <a:effectRef idx="2">
+          <a:schemeClr val="accent1"/>
+        </a:effectRef>
+        <a:fontRef idx="minor">
+          <a:schemeClr val="lt1"/>
+        </a:fontRef>
+      </a:style>
+    </a:spDef>
     <a:lnDef>
       <a:spPr/>
       <a:bodyPr/>
@@ -11951,10 +11622,5 @@
     </a:lnDef>
   </a:objectDefaults>
   <a:extraClrSchemeLst/>
-  <a:extLst>
-    <a:ext uri="{05A4C25C-085E-4340-85A3-A5531E510DB2}">
-      <thm15:themeFamily xmlns:thm15="http://schemas.microsoft.com/office/thememl/2012/main" name="Office Theme" id="{2E142A2C-CD16-42D6-873A-C26D2A0506FA}" vid="{1BDDFF52-6CD6-40A5-AB3C-68EB2F1E4D0A}"/>
-    </a:ext>
-  </a:extLst>
 </a:theme>
 </file>
</xml_diff>